<commit_message>
Update BCSE497J_Review3_Presentation.pptx: clean formatting, conference paper outcome, readable font sizes
</commit_message>
<xml_diff>
--- a/docs/BCSE497J_Review3_Presentation.pptx
+++ b/docs/BCSE497J_Review3_Presentation.pptx
@@ -3813,9 +3813,9 @@
           <a:lstStyle/>
           <a:p>
             <a:pPr algn="ctr">
-              <a:defRPr sz="1900" b="1">
-                <a:solidFill>
-                  <a:srgbClr val="102C57"/>
+              <a:defRPr sz="1800" b="1">
+                <a:solidFill>
+                  <a:srgbClr val="103460"/>
                 </a:solidFill>
                 <a:latin typeface="Calibri"/>
               </a:defRPr>
@@ -3830,11 +3830,11 @@
           </a:p>
           <a:p>
             <a:pPr algn="ctr">
-              <a:defRPr sz="2300" b="1">
-                <a:solidFill>
-                  <a:srgbClr val="1E50A0"/>
-                </a:solidFill>
-                <a:latin typeface="Calibri"/>
+              <a:defRPr sz="2600" b="1">
+                <a:solidFill>
+                  <a:srgbClr val="002B5C"/>
+                </a:solidFill>
+                <a:latin typeface="Times New Roman"/>
               </a:defRPr>
             </a:pPr>
             <a:r>
@@ -3877,10 +3877,11 @@
               <a:spcBef>
                 <a:spcPts val="200"/>
               </a:spcBef>
-              <a:defRPr b="1" sz="1400">
-                <a:solidFill>
-                  <a:srgbClr val="102C57"/>
-                </a:solidFill>
+              <a:defRPr b="1" sz="1600">
+                <a:solidFill>
+                  <a:srgbClr val="103460"/>
+                </a:solidFill>
+                <a:latin typeface="Calibri"/>
               </a:defRPr>
             </a:pPr>
             <a:r>
@@ -3893,10 +3894,11 @@
           </a:p>
           <a:p>
             <a:pPr algn="ctr">
-              <a:defRPr sz="1350" b="1">
-                <a:solidFill>
-                  <a:srgbClr val="212529"/>
-                </a:solidFill>
+              <a:defRPr sz="1700" b="1">
+                <a:solidFill>
+                  <a:srgbClr val="1E1E1E"/>
+                </a:solidFill>
+                <a:latin typeface="Calibri"/>
               </a:defRPr>
             </a:pPr>
             <a:r>
@@ -3910,10 +3912,11 @@
           </a:p>
           <a:p>
             <a:pPr algn="ctr">
-              <a:defRPr b="1" sz="1400">
-                <a:solidFill>
-                  <a:srgbClr val="102C57"/>
-                </a:solidFill>
+              <a:defRPr b="1" sz="1600">
+                <a:solidFill>
+                  <a:srgbClr val="103460"/>
+                </a:solidFill>
+                <a:latin typeface="Calibri"/>
               </a:defRPr>
             </a:pPr>
             <a:r>
@@ -3922,10 +3925,11 @@
           </a:p>
           <a:p>
             <a:pPr algn="ctr">
-              <a:defRPr sz="1450" b="1">
-                <a:solidFill>
-                  <a:srgbClr val="1E50A0"/>
-                </a:solidFill>
+              <a:defRPr sz="1700" b="1">
+                <a:solidFill>
+                  <a:srgbClr val="1E1E1E"/>
+                </a:solidFill>
+                <a:latin typeface="Calibri"/>
               </a:defRPr>
             </a:pPr>
             <a:r>
@@ -3934,10 +3938,11 @@
           </a:p>
           <a:p>
             <a:pPr algn="ctr">
-              <a:defRPr sz="1150">
+              <a:defRPr sz="1400">
                 <a:solidFill>
                   <a:srgbClr val="646464"/>
                 </a:solidFill>
+                <a:latin typeface="Calibri"/>
               </a:defRPr>
             </a:pPr>
             <a:r>
@@ -4180,8 +4185,8 @@
           <p:nvPr/>
         </p:nvGraphicFramePr>
         <p:xfrm>
-          <a:off x="731520" y="1234440"/>
-          <a:ext cx="10698480" cy="4434840"/>
+          <a:off x="731520" y="1188720"/>
+          <a:ext cx="10698480" cy="4846320"/>
         </p:xfrm>
         <a:graphic>
           <a:graphicData uri="http://schemas.openxmlformats.org/drawingml/2006/table">
@@ -4209,6 +4214,12 @@
                         </a:defRPr>
                       </a:pPr>
                       <a:r>
+                        <a:rPr sz="1400" b="1">
+                          <a:solidFill>
+                            <a:srgbClr val="FFFFFF"/>
+                          </a:solidFill>
+                          <a:latin typeface="Calibri"/>
+                        </a:rPr>
                         <a:t>Module Name</a:t>
                       </a:r>
                     </a:p>
@@ -4233,6 +4244,12 @@
                         </a:defRPr>
                       </a:pPr>
                       <a:r>
+                        <a:rPr sz="1400" b="1">
+                          <a:solidFill>
+                            <a:srgbClr val="FFFFFF"/>
+                          </a:solidFill>
+                          <a:latin typeface="Calibri"/>
+                        </a:rPr>
                         <a:t>Technology Stack</a:t>
                       </a:r>
                     </a:p>
@@ -4257,6 +4274,12 @@
                         </a:defRPr>
                       </a:pPr>
                       <a:r>
+                        <a:rPr sz="1400" b="1">
+                          <a:solidFill>
+                            <a:srgbClr val="FFFFFF"/>
+                          </a:solidFill>
+                          <a:latin typeface="Calibri"/>
+                        </a:rPr>
                         <a:t>Core Functionality &amp; Architectural Responsibility</a:t>
                       </a:r>
                     </a:p>
@@ -4283,6 +4306,12 @@
                         </a:defRPr>
                       </a:pPr>
                       <a:r>
+                        <a:rPr sz="1250" b="1">
+                          <a:solidFill>
+                            <a:srgbClr val="1E1E1E"/>
+                          </a:solidFill>
+                          <a:latin typeface="Calibri"/>
+                        </a:rPr>
                         <a:t>Traffic Generator &amp; Simulator</a:t>
                       </a:r>
                     </a:p>
@@ -4307,6 +4336,12 @@
                         </a:defRPr>
                       </a:pPr>
                       <a:r>
+                        <a:rPr sz="1250" b="1">
+                          <a:solidFill>
+                            <a:srgbClr val="1E1E1E"/>
+                          </a:solidFill>
+                          <a:latin typeface="Calibri"/>
+                        </a:rPr>
                         <a:t>Java 21, Spring Boot 3</a:t>
                       </a:r>
                     </a:p>
@@ -4331,6 +4366,12 @@
                         </a:defRPr>
                       </a:pPr>
                       <a:r>
+                        <a:rPr sz="1250">
+                          <a:solidFill>
+                            <a:srgbClr val="1E1E1E"/>
+                          </a:solidFill>
+                          <a:latin typeface="Calibri"/>
+                        </a:rPr>
                         <a:t>Simulates realistic multi-protocol enterprise background traffic and injects mathematically distinct malicious signatures for 6 attack types.</a:t>
                       </a:r>
                     </a:p>
@@ -4357,6 +4398,12 @@
                         </a:defRPr>
                       </a:pPr>
                       <a:r>
+                        <a:rPr sz="1250" b="1">
+                          <a:solidFill>
+                            <a:srgbClr val="1E1E1E"/>
+                          </a:solidFill>
+                          <a:latin typeface="Calibri"/>
+                        </a:rPr>
                         <a:t>Flow Aggregator &amp; Heuristics</a:t>
                       </a:r>
                     </a:p>
@@ -4381,6 +4428,12 @@
                         </a:defRPr>
                       </a:pPr>
                       <a:r>
+                        <a:rPr sz="1250" b="1">
+                          <a:solidFill>
+                            <a:srgbClr val="1E1E1E"/>
+                          </a:solidFill>
+                          <a:latin typeface="Calibri"/>
+                        </a:rPr>
                         <a:t>Java 21, Spring Boot 3</a:t>
                       </a:r>
                     </a:p>
@@ -4405,6 +4458,12 @@
                         </a:defRPr>
                       </a:pPr>
                       <a:r>
+                        <a:rPr sz="1250">
+                          <a:solidFill>
+                            <a:srgbClr val="1E1E1E"/>
+                          </a:solidFill>
+                          <a:latin typeface="Calibri"/>
+                        </a:rPr>
                         <a:t>Aggregates packet streams into statistical flow windows; extracts 9 engineered features (pps, bps, port diversity, byte variance, avg packet size).</a:t>
                       </a:r>
                     </a:p>
@@ -4431,6 +4490,12 @@
                         </a:defRPr>
                       </a:pPr>
                       <a:r>
+                        <a:rPr sz="1250" b="1">
+                          <a:solidFill>
+                            <a:srgbClr val="1E1E1E"/>
+                          </a:solidFill>
+                          <a:latin typeface="Calibri"/>
+                        </a:rPr>
                         <a:t>ML Anomaly Detection Engine</a:t>
                       </a:r>
                     </a:p>
@@ -4455,6 +4520,12 @@
                         </a:defRPr>
                       </a:pPr>
                       <a:r>
+                        <a:rPr sz="1250" b="1">
+                          <a:solidFill>
+                            <a:srgbClr val="1E1E1E"/>
+                          </a:solidFill>
+                          <a:latin typeface="Calibri"/>
+                        </a:rPr>
                         <a:t>Python 3.11, FastAPI, scikit-learn</a:t>
                       </a:r>
                     </a:p>
@@ -4479,6 +4550,12 @@
                         </a:defRPr>
                       </a:pPr>
                       <a:r>
+                        <a:rPr sz="1250">
+                          <a:solidFill>
+                            <a:srgbClr val="1E1E1E"/>
+                          </a:solidFill>
+                          <a:latin typeface="Calibri"/>
+                        </a:rPr>
                         <a:t>Hosts per-node unsupervised Isolation Forest models; scores incoming flow heuristics without requiring pre-labeled training attack datasets.</a:t>
                       </a:r>
                     </a:p>
@@ -4505,6 +4582,12 @@
                         </a:defRPr>
                       </a:pPr>
                       <a:r>
+                        <a:rPr sz="1250" b="1">
+                          <a:solidFill>
+                            <a:srgbClr val="1E1E1E"/>
+                          </a:solidFill>
+                          <a:latin typeface="Calibri"/>
+                        </a:rPr>
                         <a:t>Explainable AI (XAI) Module</a:t>
                       </a:r>
                     </a:p>
@@ -4529,6 +4612,12 @@
                         </a:defRPr>
                       </a:pPr>
                       <a:r>
+                        <a:rPr sz="1250" b="1">
+                          <a:solidFill>
+                            <a:srgbClr val="1E1E1E"/>
+                          </a:solidFill>
+                          <a:latin typeface="Calibri"/>
+                        </a:rPr>
                         <a:t>Python, NumPy Perturbation</a:t>
                       </a:r>
                     </a:p>
@@ -4553,6 +4642,12 @@
                         </a:defRPr>
                       </a:pPr>
                       <a:r>
+                        <a:rPr sz="1250">
+                          <a:solidFill>
+                            <a:srgbClr val="1E1E1E"/>
+                          </a:solidFill>
+                          <a:latin typeface="Calibri"/>
+                        </a:rPr>
                         <a:t>Performs feature perturbation analysis to quantify individual feature contributions to the anomaly score, identifying the primary attack heuristic.</a:t>
                       </a:r>
                     </a:p>
@@ -4579,6 +4674,12 @@
                         </a:defRPr>
                       </a:pPr>
                       <a:r>
+                        <a:rPr sz="1250" b="1">
+                          <a:solidFill>
+                            <a:srgbClr val="1E1E1E"/>
+                          </a:solidFill>
+                          <a:latin typeface="Calibri"/>
+                        </a:rPr>
                         <a:t>Trust &amp; Mitigation Manager</a:t>
                       </a:r>
                     </a:p>
@@ -4603,6 +4704,12 @@
                         </a:defRPr>
                       </a:pPr>
                       <a:r>
+                        <a:rPr sz="1250" b="1">
+                          <a:solidFill>
+                            <a:srgbClr val="1E1E1E"/>
+                          </a:solidFill>
+                          <a:latin typeface="Calibri"/>
+                        </a:rPr>
                         <a:t>Java 21, Spring Boot 3</a:t>
                       </a:r>
                     </a:p>
@@ -4627,6 +4734,12 @@
                         </a:defRPr>
                       </a:pPr>
                       <a:r>
+                        <a:rPr sz="1250">
+                          <a:solidFill>
+                            <a:srgbClr val="1E1E1E"/>
+                          </a:solidFill>
+                          <a:latin typeface="Calibri"/>
+                        </a:rPr>
                         <a:t>Manages dynamic node trust scores; applies aggressive trust penalties (2.5/tick) on detected anomalies and triggers automated quarantine at trust &lt; 30.</a:t>
                       </a:r>
                     </a:p>
@@ -4653,6 +4766,12 @@
                         </a:defRPr>
                       </a:pPr>
                       <a:r>
+                        <a:rPr sz="1250" b="1">
+                          <a:solidFill>
+                            <a:srgbClr val="1E1E1E"/>
+                          </a:solidFill>
+                          <a:latin typeface="Calibri"/>
+                        </a:rPr>
                         <a:t>Federated Aggregator (FedAvg)</a:t>
                       </a:r>
                     </a:p>
@@ -4677,6 +4796,12 @@
                         </a:defRPr>
                       </a:pPr>
                       <a:r>
+                        <a:rPr sz="1250" b="1">
+                          <a:solidFill>
+                            <a:srgbClr val="1E1E1E"/>
+                          </a:solidFill>
+                          <a:latin typeface="Calibri"/>
+                        </a:rPr>
                         <a:t>Java Engine + FastAPI Server</a:t>
                       </a:r>
                     </a:p>
@@ -4701,6 +4826,12 @@
                         </a:defRPr>
                       </a:pPr>
                       <a:r>
+                        <a:rPr sz="1250">
+                          <a:solidFill>
+                            <a:srgbClr val="1E1E1E"/>
+                          </a:solidFill>
+                          <a:latin typeface="Calibri"/>
+                        </a:rPr>
                         <a:t>Performs trust-weighted Federated Averaging of local model parameters every 20 ticks; filters out quarantined nodes to guarantee poisoning resilience.</a:t>
                       </a:r>
                     </a:p>
@@ -4727,6 +4858,12 @@
                         </a:defRPr>
                       </a:pPr>
                       <a:r>
+                        <a:rPr sz="1250" b="1">
+                          <a:solidFill>
+                            <a:srgbClr val="1E1E1E"/>
+                          </a:solidFill>
+                          <a:latin typeface="Calibri"/>
+                        </a:rPr>
                         <a:t>SOC Command Dashboard</a:t>
                       </a:r>
                     </a:p>
@@ -4751,6 +4888,12 @@
                         </a:defRPr>
                       </a:pPr>
                       <a:r>
+                        <a:rPr sz="1250" b="1">
+                          <a:solidFill>
+                            <a:srgbClr val="1E1E1E"/>
+                          </a:solidFill>
+                          <a:latin typeface="Calibri"/>
+                        </a:rPr>
                         <a:t>React 18, Vite, ReactFlow, STOMP</a:t>
                       </a:r>
                     </a:p>
@@ -4775,6 +4918,12 @@
                         </a:defRPr>
                       </a:pPr>
                       <a:r>
+                        <a:rPr sz="1250">
+                          <a:solidFill>
+                            <a:srgbClr val="1E1E1E"/>
+                          </a:solidFill>
+                          <a:latin typeface="Calibri"/>
+                        </a:rPr>
                         <a:t>Provides full-duplex WebSocket visualization of enterprise network topology, interactive attack injector, live security timeline, and DPI flow heuristics.</a:t>
                       </a:r>
                     </a:p>
@@ -5017,8 +5166,8 @@
           <p:nvPr/>
         </p:nvGraphicFramePr>
         <p:xfrm>
-          <a:off x="731520" y="1234440"/>
-          <a:ext cx="10698480" cy="4434840"/>
+          <a:off x="731520" y="1188720"/>
+          <a:ext cx="10698480" cy="4846320"/>
         </p:xfrm>
         <a:graphic>
           <a:graphicData uri="http://schemas.openxmlformats.org/drawingml/2006/table">
@@ -5047,6 +5196,12 @@
                         </a:defRPr>
                       </a:pPr>
                       <a:r>
+                        <a:rPr sz="1400" b="1">
+                          <a:solidFill>
+                            <a:srgbClr val="FFFFFF"/>
+                          </a:solidFill>
+                          <a:latin typeface="Calibri"/>
+                        </a:rPr>
                         <a:t>Evaluation Metric</a:t>
                       </a:r>
                     </a:p>
@@ -5071,6 +5226,12 @@
                         </a:defRPr>
                       </a:pPr>
                       <a:r>
+                        <a:rPr sz="1400" b="1">
+                          <a:solidFill>
+                            <a:srgbClr val="FFFFFF"/>
+                          </a:solidFill>
+                          <a:latin typeface="Calibri"/>
+                        </a:rPr>
                         <a:t>Experimental Result</a:t>
                       </a:r>
                     </a:p>
@@ -5095,6 +5256,12 @@
                         </a:defRPr>
                       </a:pPr>
                       <a:r>
+                        <a:rPr sz="1400" b="1">
+                          <a:solidFill>
+                            <a:srgbClr val="FFFFFF"/>
+                          </a:solidFill>
+                          <a:latin typeface="Calibri"/>
+                        </a:rPr>
                         <a:t>Target / Baseline</a:t>
                       </a:r>
                     </a:p>
@@ -5119,6 +5286,12 @@
                         </a:defRPr>
                       </a:pPr>
                       <a:r>
+                        <a:rPr sz="1400" b="1">
+                          <a:solidFill>
+                            <a:srgbClr val="FFFFFF"/>
+                          </a:solidFill>
+                          <a:latin typeface="Calibri"/>
+                        </a:rPr>
                         <a:t>Performance Analysis &amp; Significance</a:t>
                       </a:r>
                     </a:p>
@@ -5145,6 +5318,12 @@
                         </a:defRPr>
                       </a:pPr>
                       <a:r>
+                        <a:rPr sz="1300" b="1">
+                          <a:solidFill>
+                            <a:srgbClr val="1E1E1E"/>
+                          </a:solidFill>
+                          <a:latin typeface="Calibri"/>
+                        </a:rPr>
                         <a:t>Attack Detection Rate</a:t>
                       </a:r>
                     </a:p>
@@ -5169,6 +5348,12 @@
                         </a:defRPr>
                       </a:pPr>
                       <a:r>
+                        <a:rPr sz="1300" b="1">
+                          <a:solidFill>
+                            <a:srgbClr val="1E1E1E"/>
+                          </a:solidFill>
+                          <a:latin typeface="Calibri"/>
+                        </a:rPr>
                         <a:t>100% (6/6 profiles)</a:t>
                       </a:r>
                     </a:p>
@@ -5193,6 +5378,12 @@
                         </a:defRPr>
                       </a:pPr>
                       <a:r>
+                        <a:rPr sz="1300">
+                          <a:solidFill>
+                            <a:srgbClr val="1E1E1E"/>
+                          </a:solidFill>
+                          <a:latin typeface="Calibri"/>
+                        </a:rPr>
                         <a:t>&gt; 95.0%</a:t>
                       </a:r>
                     </a:p>
@@ -5217,6 +5408,12 @@
                         </a:defRPr>
                       </a:pPr>
                       <a:r>
+                        <a:rPr sz="1300">
+                          <a:solidFill>
+                            <a:srgbClr val="1E1E1E"/>
+                          </a:solidFill>
+                          <a:latin typeface="Calibri"/>
+                        </a:rPr>
                         <a:t>Isolation Forest successfully identifies DDoS, Port Scan, Brute Force, Malware Beacon, Exfiltration, Recon as statistical outliers.</a:t>
                       </a:r>
                     </a:p>
@@ -5243,6 +5440,12 @@
                         </a:defRPr>
                       </a:pPr>
                       <a:r>
+                        <a:rPr sz="1300" b="1">
+                          <a:solidFill>
+                            <a:srgbClr val="1E1E1E"/>
+                          </a:solidFill>
+                          <a:latin typeface="Calibri"/>
+                        </a:rPr>
                         <a:t>End-to-End Latency</a:t>
                       </a:r>
                     </a:p>
@@ -5267,6 +5470,12 @@
                         </a:defRPr>
                       </a:pPr>
                       <a:r>
+                        <a:rPr sz="1300" b="1">
+                          <a:solidFill>
+                            <a:srgbClr val="1E1E1E"/>
+                          </a:solidFill>
+                          <a:latin typeface="Calibri"/>
+                        </a:rPr>
                         <a:t>385 ms – 480 ms</a:t>
                       </a:r>
                     </a:p>
@@ -5291,6 +5500,12 @@
                         </a:defRPr>
                       </a:pPr>
                       <a:r>
+                        <a:rPr sz="1300">
+                          <a:solidFill>
+                            <a:srgbClr val="1E1E1E"/>
+                          </a:solidFill>
+                          <a:latin typeface="Calibri"/>
+                        </a:rPr>
                         <a:t>&lt; 1000 ms</a:t>
                       </a:r>
                     </a:p>
@@ -5315,6 +5530,12 @@
                         </a:defRPr>
                       </a:pPr>
                       <a:r>
+                        <a:rPr sz="1300">
+                          <a:solidFill>
+                            <a:srgbClr val="1E1E1E"/>
+                          </a:solidFill>
+                          <a:latin typeface="Calibri"/>
+                        </a:rPr>
                         <a:t>Sub-second turnaround from packet generation through flow aggregation, ML scoring, and WebSocket alert dispatch.</a:t>
                       </a:r>
                     </a:p>
@@ -5341,6 +5562,12 @@
                         </a:defRPr>
                       </a:pPr>
                       <a:r>
+                        <a:rPr sz="1300" b="1">
+                          <a:solidFill>
+                            <a:srgbClr val="1E1E1E"/>
+                          </a:solidFill>
+                          <a:latin typeface="Calibri"/>
+                        </a:rPr>
                         <a:t>False Positive Rate</a:t>
                       </a:r>
                     </a:p>
@@ -5365,6 +5592,12 @@
                         </a:defRPr>
                       </a:pPr>
                       <a:r>
+                        <a:rPr sz="1300" b="1">
+                          <a:solidFill>
+                            <a:srgbClr val="1E1E1E"/>
+                          </a:solidFill>
+                          <a:latin typeface="Calibri"/>
+                        </a:rPr>
                         <a:t>1.6% (normal baseline)</a:t>
                       </a:r>
                     </a:p>
@@ -5389,6 +5622,12 @@
                         </a:defRPr>
                       </a:pPr>
                       <a:r>
+                        <a:rPr sz="1300">
+                          <a:solidFill>
+                            <a:srgbClr val="1E1E1E"/>
+                          </a:solidFill>
+                          <a:latin typeface="Calibri"/>
+                        </a:rPr>
                         <a:t>&lt; 5.0%</a:t>
                       </a:r>
                     </a:p>
@@ -5413,6 +5652,12 @@
                         </a:defRPr>
                       </a:pPr>
                       <a:r>
+                        <a:rPr sz="1300">
+                          <a:solidFill>
+                            <a:srgbClr val="1E1E1E"/>
+                          </a:solidFill>
+                          <a:latin typeface="Calibri"/>
+                        </a:rPr>
                         <a:t>Heuristic normalization with StandardScaler ensures high specificity against benign burst traffic.</a:t>
                       </a:r>
                     </a:p>
@@ -5439,6 +5684,12 @@
                         </a:defRPr>
                       </a:pPr>
                       <a:r>
+                        <a:rPr sz="1300" b="1">
+                          <a:solidFill>
+                            <a:srgbClr val="1E1E1E"/>
+                          </a:solidFill>
+                          <a:latin typeface="Calibri"/>
+                        </a:rPr>
                         <a:t>Source Attribution Accuracy</a:t>
                       </a:r>
                     </a:p>
@@ -5463,6 +5714,12 @@
                         </a:defRPr>
                       </a:pPr>
                       <a:r>
+                        <a:rPr sz="1300" b="1">
+                          <a:solidFill>
+                            <a:srgbClr val="1E1E1E"/>
+                          </a:solidFill>
+                          <a:latin typeface="Calibri"/>
+                        </a:rPr>
                         <a:t>100% (Attacker Node)</a:t>
                       </a:r>
                     </a:p>
@@ -5487,6 +5744,12 @@
                         </a:defRPr>
                       </a:pPr>
                       <a:r>
+                        <a:rPr sz="1300">
+                          <a:solidFill>
+                            <a:srgbClr val="1E1E1E"/>
+                          </a:solidFill>
+                          <a:latin typeface="Calibri"/>
+                        </a:rPr>
                         <a:t>&gt; 95.0%</a:t>
                       </a:r>
                     </a:p>
@@ -5511,6 +5774,12 @@
                         </a:defRPr>
                       </a:pPr>
                       <a:r>
+                        <a:rPr sz="1300">
+                          <a:solidFill>
+                            <a:srgbClr val="1E1E1E"/>
+                          </a:solidFill>
+                          <a:latin typeface="Calibri"/>
+                        </a:rPr>
                         <a:t>IP/TCP header tracing correctly penalizes and quarantines the attacking node, preventing accidental victim denial of service.</a:t>
                       </a:r>
                     </a:p>
@@ -5537,6 +5806,12 @@
                         </a:defRPr>
                       </a:pPr>
                       <a:r>
+                        <a:rPr sz="1300" b="1">
+                          <a:solidFill>
+                            <a:srgbClr val="1E1E1E"/>
+                          </a:solidFill>
+                          <a:latin typeface="Calibri"/>
+                        </a:rPr>
                         <a:t>FedAvg Model Convergence</a:t>
                       </a:r>
                     </a:p>
@@ -5561,6 +5836,12 @@
                         </a:defRPr>
                       </a:pPr>
                       <a:r>
+                        <a:rPr sz="1300" b="1">
+                          <a:solidFill>
+                            <a:srgbClr val="1E1E1E"/>
+                          </a:solidFill>
+                          <a:latin typeface="Calibri"/>
+                        </a:rPr>
                         <a:t>3 Rounds (~30 sec)</a:t>
                       </a:r>
                     </a:p>
@@ -5585,6 +5866,12 @@
                         </a:defRPr>
                       </a:pPr>
                       <a:r>
+                        <a:rPr sz="1300">
+                          <a:solidFill>
+                            <a:srgbClr val="1E1E1E"/>
+                          </a:solidFill>
+                          <a:latin typeface="Calibri"/>
+                        </a:rPr>
                         <a:t>&lt; 10 Rounds</a:t>
                       </a:r>
                     </a:p>
@@ -5609,6 +5896,12 @@
                         </a:defRPr>
                       </a:pPr>
                       <a:r>
+                        <a:rPr sz="1300">
+                          <a:solidFill>
+                            <a:srgbClr val="1E1E1E"/>
+                          </a:solidFill>
+                          <a:latin typeface="Calibri"/>
+                        </a:rPr>
                         <a:t>Global aggregated Isolation Forest achieves optimal decision boundary matching centralized training performance.</a:t>
                       </a:r>
                     </a:p>
@@ -5635,6 +5928,12 @@
                         </a:defRPr>
                       </a:pPr>
                       <a:r>
+                        <a:rPr sz="1300" b="1">
+                          <a:solidFill>
+                            <a:srgbClr val="1E1E1E"/>
+                          </a:solidFill>
+                          <a:latin typeface="Calibri"/>
+                        </a:rPr>
                         <a:t>Poisoning Attack Resilience</a:t>
                       </a:r>
                     </a:p>
@@ -5659,6 +5958,12 @@
                         </a:defRPr>
                       </a:pPr>
                       <a:r>
+                        <a:rPr sz="1300" b="1">
+                          <a:solidFill>
+                            <a:srgbClr val="1E1E1E"/>
+                          </a:solidFill>
+                          <a:latin typeface="Calibri"/>
+                        </a:rPr>
                         <a:t>0% Contamination</a:t>
                       </a:r>
                     </a:p>
@@ -5683,6 +5988,12 @@
                         </a:defRPr>
                       </a:pPr>
                       <a:r>
+                        <a:rPr sz="1300">
+                          <a:solidFill>
+                            <a:srgbClr val="1E1E1E"/>
+                          </a:solidFill>
+                          <a:latin typeface="Calibri"/>
+                        </a:rPr>
                         <a:t>0.0%</a:t>
                       </a:r>
                     </a:p>
@@ -5707,6 +6018,12 @@
                         </a:defRPr>
                       </a:pPr>
                       <a:r>
+                        <a:rPr sz="1300">
+                          <a:solidFill>
+                            <a:srgbClr val="1E1E1E"/>
+                          </a:solidFill>
+                          <a:latin typeface="Calibri"/>
+                        </a:rPr>
                         <a:t>Trust-weighted FedAvg allocates zero weight to quarantined nodes, completely neutralizing adversarial parameter poisoning.</a:t>
                       </a:r>
                     </a:p>
@@ -5733,6 +6050,12 @@
                         </a:defRPr>
                       </a:pPr>
                       <a:r>
+                        <a:rPr sz="1300" b="1">
+                          <a:solidFill>
+                            <a:srgbClr val="1E1E1E"/>
+                          </a:solidFill>
+                          <a:latin typeface="Calibri"/>
+                        </a:rPr>
                         <a:t>System Telemetry Throughput</a:t>
                       </a:r>
                     </a:p>
@@ -5757,6 +6080,12 @@
                         </a:defRPr>
                       </a:pPr>
                       <a:r>
+                        <a:rPr sz="1300" b="1">
+                          <a:solidFill>
+                            <a:srgbClr val="1E1E1E"/>
+                          </a:solidFill>
+                          <a:latin typeface="Calibri"/>
+                        </a:rPr>
                         <a:t>500+ packets/sec</a:t>
                       </a:r>
                     </a:p>
@@ -5781,6 +6110,12 @@
                         </a:defRPr>
                       </a:pPr>
                       <a:r>
+                        <a:rPr sz="1300">
+                          <a:solidFill>
+                            <a:srgbClr val="1E1E1E"/>
+                          </a:solidFill>
+                          <a:latin typeface="Calibri"/>
+                        </a:rPr>
                         <a:t>&gt; 200 pps</a:t>
                       </a:r>
                     </a:p>
@@ -5805,6 +6140,12 @@
                         </a:defRPr>
                       </a:pPr>
                       <a:r>
+                        <a:rPr sz="1300">
+                          <a:solidFill>
+                            <a:srgbClr val="1E1E1E"/>
+                          </a:solidFill>
+                          <a:latin typeface="Calibri"/>
+                        </a:rPr>
                         <a:t>STOMP WebSocket maintains fluid bi-directional streaming at a sustained 60 FPS UI rendering performance.</a:t>
                       </a:r>
                     </a:p>
@@ -6047,7 +6388,7 @@
         <p:spPr>
           <a:xfrm>
             <a:off x="731520" y="1234440"/>
-            <a:ext cx="5212080" cy="4434840"/>
+            <a:ext cx="5120640" cy="4846320"/>
           </a:xfrm>
           <a:prstGeom prst="rect">
             <a:avLst/>
@@ -6071,122 +6412,138 @@
               </a:defRPr>
             </a:pPr>
             <a:r>
+              <a:rPr sz="1800" b="1">
+                <a:solidFill>
+                  <a:srgbClr val="103460"/>
+                </a:solidFill>
+                <a:latin typeface="Calibri"/>
+              </a:rPr>
               <a:t>Key Achievements &amp; Conclusion</a:t>
             </a:r>
           </a:p>
           <a:p>
             <a:pPr>
               <a:spcAft>
-                <a:spcPts val="500"/>
+                <a:spcPts val="600"/>
               </a:spcAft>
-              <a:defRPr b="1" sz="1100">
-                <a:solidFill>
-                  <a:srgbClr val="102C57"/>
-                </a:solidFill>
-              </a:defRPr>
             </a:pPr>
             <a:r>
+              <a:rPr sz="1450" b="1">
+                <a:solidFill>
+                  <a:srgbClr val="103460"/>
+                </a:solidFill>
+                <a:latin typeface="Calibri"/>
+              </a:rPr>
               <a:t>•  Privacy-Preserving Defense: </a:t>
             </a:r>
             <a:r>
-              <a:rPr b="0" sz="1050">
-                <a:solidFill>
-                  <a:srgbClr val="212529"/>
-                </a:solidFill>
+              <a:rPr sz="1400">
+                <a:solidFill>
+                  <a:srgbClr val="1E1E1E"/>
+                </a:solidFill>
+                <a:latin typeface="Calibri"/>
               </a:rPr>
-              <a:t>Demonstrated that distributed enterprise networks can collaborate on anomaly detection without exposing sensitive raw packet data.</a:t>
+              <a:t>Demonstrated distributed collaboration without exposing sensitive raw packet data.</a:t>
             </a:r>
           </a:p>
           <a:p>
             <a:pPr>
               <a:spcAft>
-                <a:spcPts val="500"/>
+                <a:spcPts val="600"/>
               </a:spcAft>
-              <a:defRPr b="1" sz="1100">
-                <a:solidFill>
-                  <a:srgbClr val="102C57"/>
-                </a:solidFill>
-              </a:defRPr>
             </a:pPr>
             <a:r>
+              <a:rPr sz="1450" b="1">
+                <a:solidFill>
+                  <a:srgbClr val="103460"/>
+                </a:solidFill>
+                <a:latin typeface="Calibri"/>
+              </a:rPr>
               <a:t>•  Unsupervised Zero-Day Detection: </a:t>
             </a:r>
             <a:r>
-              <a:rPr b="0" sz="1050">
-                <a:solidFill>
-                  <a:srgbClr val="212529"/>
-                </a:solidFill>
+              <a:rPr sz="1400">
+                <a:solidFill>
+                  <a:srgbClr val="1E1E1E"/>
+                </a:solidFill>
+                <a:latin typeface="Calibri"/>
               </a:rPr>
-              <a:t>Isolation Forest successfully detects 6 complex attack vectors as anomalies without relying on pre-labeled training datasets.</a:t>
+              <a:t>Isolation Forest detects 6 complex attack vectors as anomalies without pre-labeled data.</a:t>
             </a:r>
           </a:p>
           <a:p>
             <a:pPr>
               <a:spcAft>
-                <a:spcPts val="500"/>
+                <a:spcPts val="600"/>
               </a:spcAft>
-              <a:defRPr b="1" sz="1100">
-                <a:solidFill>
-                  <a:srgbClr val="102C57"/>
-                </a:solidFill>
-              </a:defRPr>
             </a:pPr>
             <a:r>
+              <a:rPr sz="1450" b="1">
+                <a:solidFill>
+                  <a:srgbClr val="103460"/>
+                </a:solidFill>
+                <a:latin typeface="Calibri"/>
+              </a:rPr>
               <a:t>•  Trust-Weighted Security: </a:t>
             </a:r>
             <a:r>
-              <a:rPr b="0" sz="1050">
-                <a:solidFill>
-                  <a:srgbClr val="212529"/>
-                </a:solidFill>
+              <a:rPr sz="1400">
+                <a:solidFill>
+                  <a:srgbClr val="1E1E1E"/>
+                </a:solidFill>
+                <a:latin typeface="Calibri"/>
               </a:rPr>
-              <a:t>Dynamic trust scoring actively isolates malicious participants and eliminates model poisoning vulnerabilities in FedAvg.</a:t>
+              <a:t>Dynamic trust scoring actively isolates malicious participants and eliminates poisoning in FedAvg.</a:t>
             </a:r>
           </a:p>
           <a:p>
             <a:pPr>
               <a:spcAft>
-                <a:spcPts val="500"/>
+                <a:spcPts val="600"/>
               </a:spcAft>
-              <a:defRPr b="1" sz="1100">
-                <a:solidFill>
-                  <a:srgbClr val="102C57"/>
-                </a:solidFill>
-              </a:defRPr>
             </a:pPr>
             <a:r>
+              <a:rPr sz="1450" b="1">
+                <a:solidFill>
+                  <a:srgbClr val="103460"/>
+                </a:solidFill>
+                <a:latin typeface="Calibri"/>
+              </a:rPr>
               <a:t>•  Explainable Security Operations: </a:t>
             </a:r>
             <a:r>
-              <a:rPr b="0" sz="1050">
-                <a:solidFill>
-                  <a:srgbClr val="212529"/>
-                </a:solidFill>
+              <a:rPr sz="1400">
+                <a:solidFill>
+                  <a:srgbClr val="1E1E1E"/>
+                </a:solidFill>
+                <a:latin typeface="Calibri"/>
               </a:rPr>
-              <a:t>Feature-perturbation XAI bridges the gap between machine learning predictions and actionable human-in-the-loop triage.</a:t>
+              <a:t>Feature-perturbation XAI bridges machine learning predictions and actionable human triage.</a:t>
             </a:r>
           </a:p>
           <a:p>
             <a:pPr>
               <a:spcAft>
-                <a:spcPts val="500"/>
+                <a:spcPts val="600"/>
               </a:spcAft>
-              <a:defRPr b="1" sz="1100">
-                <a:solidFill>
-                  <a:srgbClr val="102C57"/>
-                </a:solidFill>
-              </a:defRPr>
             </a:pPr>
             <a:r>
+              <a:rPr sz="1450" b="1">
+                <a:solidFill>
+                  <a:srgbClr val="103460"/>
+                </a:solidFill>
+                <a:latin typeface="Calibri"/>
+              </a:rPr>
               <a:t>•  Automated Source Quarantine: </a:t>
             </a:r>
             <a:r>
-              <a:rPr b="0" sz="1050">
-                <a:solidFill>
-                  <a:srgbClr val="212529"/>
-                </a:solidFill>
+              <a:rPr sz="1400">
+                <a:solidFill>
+                  <a:srgbClr val="1E1E1E"/>
+                </a:solidFill>
+                <a:latin typeface="Calibri"/>
               </a:rPr>
-              <a:t>TCP header attribution ensures the true attacker is quarantined, safeguarding victim availability.</a:t>
+              <a:t>TCP header attribution ensures true attacker is quarantined, safeguarding victim availability.</a:t>
             </a:r>
           </a:p>
         </p:txBody>
@@ -6200,7 +6557,7 @@
         <p:spPr>
           <a:xfrm>
             <a:off x="6217920" y="1234440"/>
-            <a:ext cx="5212080" cy="4434840"/>
+            <a:ext cx="5120640" cy="4846320"/>
           </a:xfrm>
           <a:prstGeom prst="rect">
             <a:avLst/>
@@ -6224,122 +6581,138 @@
               </a:defRPr>
             </a:pPr>
             <a:r>
+              <a:rPr sz="1800" b="1">
+                <a:solidFill>
+                  <a:srgbClr val="103460"/>
+                </a:solidFill>
+                <a:latin typeface="Calibri"/>
+              </a:rPr>
               <a:t>Future Work &amp; Extensions</a:t>
             </a:r>
           </a:p>
           <a:p>
             <a:pPr>
               <a:spcAft>
-                <a:spcPts val="500"/>
+                <a:spcPts val="600"/>
               </a:spcAft>
-              <a:defRPr b="1" sz="1100">
-                <a:solidFill>
-                  <a:srgbClr val="1E50A0"/>
-                </a:solidFill>
-              </a:defRPr>
             </a:pPr>
             <a:r>
+              <a:rPr sz="1450" b="1">
+                <a:solidFill>
+                  <a:srgbClr val="103460"/>
+                </a:solidFill>
+                <a:latin typeface="Calibri"/>
+              </a:rPr>
               <a:t>•  Physical IoT Hardware Deployment: </a:t>
             </a:r>
             <a:r>
-              <a:rPr b="0" sz="1050">
-                <a:solidFill>
-                  <a:srgbClr val="212529"/>
-                </a:solidFill>
+              <a:rPr sz="1400">
+                <a:solidFill>
+                  <a:srgbClr val="1E1E1E"/>
+                </a:solidFill>
+                <a:latin typeface="Calibri"/>
               </a:rPr>
-              <a:t>Porting lightweight anomaly client probes to physical edge devices (Raspberry Pi 4 / NVIDIA Jetson) in an embedded sensor lab testbed.</a:t>
+              <a:t>Porting lightweight anomaly client probes to physical edge devices (Raspberry Pi 4 / Jetson).</a:t>
             </a:r>
           </a:p>
           <a:p>
             <a:pPr>
               <a:spcAft>
-                <a:spcPts val="500"/>
+                <a:spcPts val="600"/>
               </a:spcAft>
-              <a:defRPr b="1" sz="1100">
-                <a:solidFill>
-                  <a:srgbClr val="1E50A0"/>
-                </a:solidFill>
-              </a:defRPr>
             </a:pPr>
             <a:r>
+              <a:rPr sz="1450" b="1">
+                <a:solidFill>
+                  <a:srgbClr val="103460"/>
+                </a:solidFill>
+                <a:latin typeface="Calibri"/>
+              </a:rPr>
               <a:t>•  Differential Privacy (DP) Guarantees: </a:t>
             </a:r>
             <a:r>
-              <a:rPr b="0" sz="1050">
-                <a:solidFill>
-                  <a:srgbClr val="212529"/>
-                </a:solidFill>
+              <a:rPr sz="1400">
+                <a:solidFill>
+                  <a:srgbClr val="1E1E1E"/>
+                </a:solidFill>
+                <a:latin typeface="Calibri"/>
               </a:rPr>
-              <a:t>Injecting calibrated Gaussian noise into local tree splits to guarantee mathematical epsilon-differential privacy during model synchronization.</a:t>
+              <a:t>Injecting calibrated Gaussian noise into tree splits for mathematical epsilon-DP privacy.</a:t>
             </a:r>
           </a:p>
           <a:p>
             <a:pPr>
               <a:spcAft>
-                <a:spcPts val="500"/>
+                <a:spcPts val="600"/>
               </a:spcAft>
-              <a:defRPr b="1" sz="1100">
-                <a:solidFill>
-                  <a:srgbClr val="1E50A0"/>
-                </a:solidFill>
-              </a:defRPr>
             </a:pPr>
             <a:r>
+              <a:rPr sz="1450" b="1">
+                <a:solidFill>
+                  <a:srgbClr val="103460"/>
+                </a:solidFill>
+                <a:latin typeface="Calibri"/>
+              </a:rPr>
               <a:t>•  Homomorphic Encryption for FedAvg: </a:t>
             </a:r>
             <a:r>
-              <a:rPr b="0" sz="1050">
-                <a:solidFill>
-                  <a:srgbClr val="212529"/>
-                </a:solidFill>
+              <a:rPr sz="1400">
+                <a:solidFill>
+                  <a:srgbClr val="1E1E1E"/>
+                </a:solidFill>
+                <a:latin typeface="Calibri"/>
               </a:rPr>
-              <a:t>Employing the Paillier cryptosystem to aggregate encrypted local Isolation Forest parameters without decryption on the aggregation server.</a:t>
+              <a:t>Employing Paillier cryptosystem to aggregate encrypted local parameters securely.</a:t>
             </a:r>
           </a:p>
           <a:p>
             <a:pPr>
               <a:spcAft>
-                <a:spcPts val="500"/>
+                <a:spcPts val="600"/>
               </a:spcAft>
-              <a:defRPr b="1" sz="1100">
-                <a:solidFill>
-                  <a:srgbClr val="1E50A0"/>
-                </a:solidFill>
-              </a:defRPr>
             </a:pPr>
             <a:r>
+              <a:rPr sz="1450" b="1">
+                <a:solidFill>
+                  <a:srgbClr val="103460"/>
+                </a:solidFill>
+                <a:latin typeface="Calibri"/>
+              </a:rPr>
               <a:t>•  Multi-Tenant Hierarchical FL: </a:t>
             </a:r>
             <a:r>
-              <a:rPr b="0" sz="1050">
-                <a:solidFill>
-                  <a:srgbClr val="212529"/>
-                </a:solidFill>
+              <a:rPr sz="1400">
+                <a:solidFill>
+                  <a:srgbClr val="1E1E1E"/>
+                </a:solidFill>
+                <a:latin typeface="Calibri"/>
               </a:rPr>
-              <a:t>Extending the FedAvg coordinator to support multi-tier hierarchical aggregation across cross-organizational enterprise autonomous systems (AS).</a:t>
+              <a:t>Extending coordinator to support multi-tier aggregation across autonomous systems (AS).</a:t>
             </a:r>
           </a:p>
           <a:p>
             <a:pPr>
               <a:spcAft>
-                <a:spcPts val="500"/>
+                <a:spcPts val="600"/>
               </a:spcAft>
-              <a:defRPr b="1" sz="1100">
-                <a:solidFill>
-                  <a:srgbClr val="1E50A0"/>
-                </a:solidFill>
-              </a:defRPr>
             </a:pPr>
             <a:r>
+              <a:rPr sz="1450" b="1">
+                <a:solidFill>
+                  <a:srgbClr val="103460"/>
+                </a:solidFill>
+                <a:latin typeface="Calibri"/>
+              </a:rPr>
               <a:t>•  Adaptive Contamination Tuning: </a:t>
             </a:r>
             <a:r>
-              <a:rPr b="0" sz="1050">
-                <a:solidFill>
-                  <a:srgbClr val="212529"/>
-                </a:solidFill>
+              <a:rPr sz="1400">
+                <a:solidFill>
+                  <a:srgbClr val="1E1E1E"/>
+                </a:solidFill>
+                <a:latin typeface="Calibri"/>
               </a:rPr>
-              <a:t>Dynamically adjusting local Isolation Forest contamination hyperparameters using rolling real-time traffic entropy.</a:t>
+              <a:t>Dynamically adjusting contamination hyperparameters using rolling real-time traffic entropy.</a:t>
             </a:r>
           </a:p>
         </p:txBody>
@@ -6542,7 +6915,7 @@
         <p:spPr>
           <a:xfrm>
             <a:off x="731520" y="1234440"/>
-            <a:ext cx="10698480" cy="4434840"/>
+            <a:ext cx="10698480" cy="4937760"/>
           </a:xfrm>
           <a:prstGeom prst="rect">
             <a:avLst/>
@@ -6557,7 +6930,7 @@
           <a:p>
             <a:pPr>
               <a:spcAft>
-                <a:spcPts val="600"/>
+                <a:spcPts val="1000"/>
               </a:spcAft>
               <a:defRPr b="1" sz="1450">
                 <a:solidFill>
@@ -6566,7 +6939,32 @@
               </a:defRPr>
             </a:pPr>
             <a:r>
+              <a:rPr sz="2000" b="1">
+                <a:solidFill>
+                  <a:srgbClr val="103460"/>
+                </a:solidFill>
+                <a:latin typeface="Calibri"/>
+              </a:rPr>
               <a:t>Review 3 Outcomes &amp; Deliverables Achieved:</a:t>
+            </a:r>
+          </a:p>
+          <a:p>
+            <a:pPr>
+              <a:spcBef>
+                <a:spcPts val="400"/>
+              </a:spcBef>
+              <a:spcAft>
+                <a:spcPts val="300"/>
+              </a:spcAft>
+            </a:pPr>
+            <a:r>
+              <a:rPr sz="1700" b="1">
+                <a:solidFill>
+                  <a:srgbClr val="0066CC"/>
+                </a:solidFill>
+                <a:latin typeface="Calibri"/>
+              </a:rPr>
+              <a:t>1. Conference Paper Submitted to NULLCON Goa 2027</a:t>
             </a:r>
           </a:p>
           <a:p>
@@ -6574,14 +6972,24 @@
               <a:spcAft>
                 <a:spcPts val="200"/>
               </a:spcAft>
-              <a:defRPr b="1" sz="1200">
-                <a:solidFill>
-                  <a:srgbClr val="1E50A0"/>
-                </a:solidFill>
-              </a:defRPr>
             </a:pPr>
             <a:r>
-              <a:t>1. Research Paper Drafted for Scopus-Indexed Conference / Journal Publication</a:t>
+              <a:rPr sz="1450" b="1">
+                <a:solidFill>
+                  <a:srgbClr val="1E1E1E"/>
+                </a:solidFill>
+                <a:latin typeface="Calibri"/>
+              </a:rPr>
+              <a:t>    •  Paper Title: </a:t>
+            </a:r>
+            <a:r>
+              <a:rPr sz="1450">
+                <a:solidFill>
+                  <a:srgbClr val="1E1E1E"/>
+                </a:solidFill>
+                <a:latin typeface="Calibri"/>
+              </a:rPr>
+              <a:t>'Explainable Federated Learning Framework for Distributed Network Anomaly Detection with Trust-Weighted Isolation Forests'</a:t>
             </a:r>
           </a:p>
           <a:p>
@@ -6589,14 +6997,24 @@
               <a:spcAft>
                 <a:spcPts val="200"/>
               </a:spcAft>
-              <a:defRPr sz="1050">
-                <a:solidFill>
-                  <a:srgbClr val="212529"/>
-                </a:solidFill>
-              </a:defRPr>
             </a:pPr>
             <a:r>
-              <a:t>   • Manuscript Title: 'Explainable Federated Learning Framework for Distributed Network Anomaly Detection with Trust-Weighted Isolation Forests'</a:t>
+              <a:rPr sz="1450" b="1">
+                <a:solidFill>
+                  <a:srgbClr val="1E1E1E"/>
+                </a:solidFill>
+                <a:latin typeface="Calibri"/>
+              </a:rPr>
+              <a:t>    •  Authors: </a:t>
+            </a:r>
+            <a:r>
+              <a:rPr sz="1450">
+                <a:solidFill>
+                  <a:srgbClr val="1E1E1E"/>
+                </a:solidFill>
+                <a:latin typeface="Calibri"/>
+              </a:rPr>
+              <a:t>Kota Bhanu Prashanth Reddy (23BCE0340), V L Vedhesh (23BCE2134), Dr. Soumyajyoti Dey (Faculty Guide)</a:t>
             </a:r>
           </a:p>
           <a:p>
@@ -6604,14 +7022,24 @@
               <a:spcAft>
                 <a:spcPts val="200"/>
               </a:spcAft>
-              <a:defRPr sz="1050">
-                <a:solidFill>
-                  <a:srgbClr val="212529"/>
-                </a:solidFill>
-              </a:defRPr>
             </a:pPr>
             <a:r>
-              <a:t>   • Authors: Kota Bhanu Prashanth Reddy (23BCE0340), V L Vedhesh (23BCE2134), Dr. Soumyajyoti Dey</a:t>
+              <a:rPr sz="1450" b="1">
+                <a:solidFill>
+                  <a:srgbClr val="1E1E1E"/>
+                </a:solidFill>
+                <a:latin typeface="Calibri"/>
+              </a:rPr>
+              <a:t>    •  Conference Venue: </a:t>
+            </a:r>
+            <a:r>
+              <a:rPr sz="1450">
+                <a:solidFill>
+                  <a:srgbClr val="1E1E1E"/>
+                </a:solidFill>
+                <a:latin typeface="Calibri"/>
+              </a:rPr>
+              <a:t>NULLCON Goa 2027 (International Cyber Security Conference) | Scopus-Indexed</a:t>
             </a:r>
           </a:p>
           <a:p>
@@ -6619,14 +7047,43 @@
               <a:spcAft>
                 <a:spcPts val="200"/>
               </a:spcAft>
-              <a:defRPr sz="1050">
-                <a:solidFill>
-                  <a:srgbClr val="212529"/>
-                </a:solidFill>
-              </a:defRPr>
             </a:pPr>
             <a:r>
-              <a:t>   • Target Venue: IEEE International Conference on Cyber Security / Distributed Computing (Scopus Indexed)</a:t>
+              <a:rPr sz="1450" b="1">
+                <a:solidFill>
+                  <a:srgbClr val="1E1E1E"/>
+                </a:solidFill>
+                <a:latin typeface="Calibri"/>
+              </a:rPr>
+              <a:t>    •  Submission Status: </a:t>
+            </a:r>
+            <a:r>
+              <a:rPr sz="1450">
+                <a:solidFill>
+                  <a:srgbClr val="1E1E1E"/>
+                </a:solidFill>
+                <a:latin typeface="Calibri"/>
+              </a:rPr>
+              <a:t>Proposal received confirmation issued (Submission ID: Y8PTCQ) | Under Review</a:t>
+            </a:r>
+          </a:p>
+          <a:p>
+            <a:pPr>
+              <a:spcBef>
+                <a:spcPts val="800"/>
+              </a:spcBef>
+              <a:spcAft>
+                <a:spcPts val="300"/>
+              </a:spcAft>
+            </a:pPr>
+            <a:r>
+              <a:rPr sz="1700" b="1">
+                <a:solidFill>
+                  <a:srgbClr val="00783C"/>
+                </a:solidFill>
+                <a:latin typeface="Calibri"/>
+              </a:rPr>
+              <a:t>2. Fully Functional Enterprise Software Prototype (Product Development)</a:t>
             </a:r>
           </a:p>
           <a:p>
@@ -6634,34 +7091,68 @@
               <a:spcAft>
                 <a:spcPts val="200"/>
               </a:spcAft>
-              <a:defRPr sz="1050">
-                <a:solidFill>
-                  <a:srgbClr val="212529"/>
-                </a:solidFill>
-              </a:defRPr>
             </a:pPr>
             <a:r>
-              <a:t>   • Status: Full manuscript drafted including formal methodology, mathematical formulation, and experimental benchmarking.</a:t>
-            </a:r>
-          </a:p>
-          <a:p>
-            <a:pPr>
-              <a:defRPr sz="300"/>
-            </a:pPr>
+              <a:rPr sz="1450" b="1">
+                <a:solidFill>
+                  <a:srgbClr val="1E1E1E"/>
+                </a:solidFill>
+                <a:latin typeface="Calibri"/>
+              </a:rPr>
+              <a:t>    •  Architecture: </a:t>
+            </a:r>
+            <a:r>
+              <a:rPr sz="1450">
+                <a:solidFill>
+                  <a:srgbClr val="1E1E1E"/>
+                </a:solidFill>
+                <a:latin typeface="Calibri"/>
+              </a:rPr>
+              <a:t>3-tier microservice architecture: React 18 frontend + Spring Boot 3 engine + FastAPI ML service</a:t>
+            </a:r>
           </a:p>
           <a:p>
             <a:pPr>
               <a:spcAft>
                 <a:spcPts val="200"/>
               </a:spcAft>
-              <a:defRPr b="1" sz="1200">
-                <a:solidFill>
-                  <a:srgbClr val="1E50A0"/>
-                </a:solidFill>
-              </a:defRPr>
             </a:pPr>
             <a:r>
-              <a:t>2. Fully Functional Enterprise Software Prototype (Product Development)</a:t>
+              <a:rPr sz="1450" b="1">
+                <a:solidFill>
+                  <a:srgbClr val="1E1E1E"/>
+                </a:solidFill>
+                <a:latin typeface="Calibri"/>
+              </a:rPr>
+              <a:t>    •  Capabilities: </a:t>
+            </a:r>
+            <a:r>
+              <a:rPr sz="1450">
+                <a:solidFill>
+                  <a:srgbClr val="1E1E1E"/>
+                </a:solidFill>
+                <a:latin typeface="Calibri"/>
+              </a:rPr>
+              <a:t>16-node topology visualization, 6 live attack profiles, automated quarantine, full-duplex STOMP telemetry</a:t>
+            </a:r>
+          </a:p>
+          <a:p>
+            <a:pPr>
+              <a:spcBef>
+                <a:spcPts val="800"/>
+              </a:spcBef>
+              <a:spcAft>
+                <a:spcPts val="300"/>
+              </a:spcAft>
+            </a:pPr>
+            <a:r>
+              <a:rPr sz="1700" b="1">
+                <a:solidFill>
+                  <a:srgbClr val="103460"/>
+                </a:solidFill>
+                <a:latin typeface="Calibri"/>
+              </a:rPr>
+              <a:t>3. Outcome Verification &amp; Official Portal Submission</a:t>
             </a:r>
           </a:p>
           <a:p>
@@ -6669,14 +7160,24 @@
               <a:spcAft>
                 <a:spcPts val="200"/>
               </a:spcAft>
-              <a:defRPr sz="1050">
-                <a:solidFill>
-                  <a:srgbClr val="212529"/>
-                </a:solidFill>
-              </a:defRPr>
             </a:pPr>
             <a:r>
-              <a:t>   • Delivered a production-ready, 3-tier microservice architecture: React 18 frontend + Spring Boot 3 engine + FastAPI ML service.</a:t>
+              <a:rPr sz="1450" b="1">
+                <a:solidFill>
+                  <a:srgbClr val="1E1E1E"/>
+                </a:solidFill>
+                <a:latin typeface="Calibri"/>
+              </a:rPr>
+              <a:t>    •  Portal Verification: </a:t>
+            </a:r>
+            <a:r>
+              <a:rPr sz="1450">
+                <a:solidFill>
+                  <a:srgbClr val="1E1E1E"/>
+                </a:solidFill>
+                <a:latin typeface="Calibri"/>
+              </a:rPr>
+              <a:t>Submitted project demonstration video, proof of completion, and manuscript draft to official VIT portal</a:t>
             </a:r>
           </a:p>
           <a:p>
@@ -6684,85 +7185,25 @@
               <a:spcAft>
                 <a:spcPts val="200"/>
               </a:spcAft>
-              <a:defRPr sz="1050">
-                <a:solidFill>
-                  <a:srgbClr val="212529"/>
-                </a:solidFill>
-              </a:defRPr>
             </a:pPr>
             <a:r>
-              <a:t>   • Interactive SOC Dashboard featuring 16-node topology visualization, 6 live attack profiles, and automated node quarantine.</a:t>
-            </a:r>
-          </a:p>
-          <a:p>
-            <a:pPr>
-              <a:spcAft>
-                <a:spcPts val="200"/>
-              </a:spcAft>
-              <a:defRPr sz="1050">
-                <a:solidFill>
-                  <a:srgbClr val="212529"/>
-                </a:solidFill>
-              </a:defRPr>
-            </a:pPr>
-            <a:r>
-              <a:t>   • Full-duplex STOMP over SockJS telemetry pipeline delivering sub-second anomaly alerts and dynamic trust adjustments.</a:t>
-            </a:r>
-          </a:p>
-          <a:p>
-            <a:pPr>
-              <a:defRPr sz="300"/>
-            </a:pPr>
-          </a:p>
-          <a:p>
-            <a:pPr>
-              <a:spcAft>
-                <a:spcPts val="200"/>
-              </a:spcAft>
-              <a:defRPr b="1" sz="1200">
-                <a:solidFill>
-                  <a:srgbClr val="1E50A0"/>
-                </a:solidFill>
-              </a:defRPr>
-            </a:pPr>
-            <a:r>
-              <a:t>3. Outcome Achieved Verification &amp; Portal Submission</a:t>
-            </a:r>
-          </a:p>
-          <a:p>
-            <a:pPr>
-              <a:spcAft>
-                <a:spcPts val="200"/>
-              </a:spcAft>
-              <a:defRPr sz="1050">
-                <a:solidFill>
-                  <a:srgbClr val="212529"/>
-                </a:solidFill>
-              </a:defRPr>
-            </a:pPr>
-            <a:r>
-              <a:t>   • Proof of project completion, simulation demonstration video, and manuscript draft submitted to the official VIT portal.</a:t>
-            </a:r>
-          </a:p>
-          <a:p>
-            <a:pPr>
-              <a:spcAft>
-                <a:spcPts val="200"/>
-              </a:spcAft>
-              <a:defRPr sz="1050">
-                <a:solidFill>
-                  <a:srgbClr val="212529"/>
-                </a:solidFill>
-              </a:defRPr>
-            </a:pPr>
-            <a:r>
-              <a:t>   • Portal link verified: https://forms.gle/B9B71VPy5b9bZ9dJ8 (Submitted on or before 27 Oct 2026 as required).</a:t>
-            </a:r>
-          </a:p>
-          <a:p>
-            <a:pPr>
-              <a:defRPr sz="300"/>
-            </a:pPr>
+              <a:rPr sz="1450" b="1">
+                <a:solidFill>
+                  <a:srgbClr val="1E1E1E"/>
+                </a:solidFill>
+                <a:latin typeface="Calibri"/>
+              </a:rPr>
+              <a:t>    •  Submission Link: </a:t>
+            </a:r>
+            <a:r>
+              <a:rPr sz="1450">
+                <a:solidFill>
+                  <a:srgbClr val="1E1E1E"/>
+                </a:solidFill>
+                <a:latin typeface="Calibri"/>
+              </a:rPr>
+              <a:t>https://forms.gle/B9B71VPy5b9bZ9dJ8 (Formally submitted on or before 27 Oct 2026)</a:t>
+            </a:r>
           </a:p>
         </p:txBody>
       </p:sp>
@@ -6873,7 +7314,7 @@
         </p:nvSpPr>
         <p:spPr bwMode="auto">
           <a:xfrm>
-            <a:off x="14630400" y="1442399"/>
+            <a:off x="14630400" y="0"/>
             <a:ext cx="10515600" cy="1938992"/>
           </a:xfrm>
           <a:prstGeom prst="rect">
@@ -7032,7 +7473,7 @@
         <p:spPr>
           <a:xfrm>
             <a:off x="731520" y="1234440"/>
-            <a:ext cx="10698480" cy="4434840"/>
+            <a:ext cx="10698480" cy="4846320"/>
           </a:xfrm>
           <a:prstGeom prst="rect">
             <a:avLst/>
@@ -7046,8 +7487,11 @@
           <a:lstStyle/>
           <a:p>
             <a:pPr>
+              <a:spcBef>
+                <a:spcPts val="100"/>
+              </a:spcBef>
               <a:spcAft>
-                <a:spcPts val="500"/>
+                <a:spcPts val="600"/>
               </a:spcAft>
               <a:defRPr sz="1000">
                 <a:solidFill>
@@ -7057,13 +7501,22 @@
               </a:defRPr>
             </a:pPr>
             <a:r>
+              <a:rPr sz="1300">
+                <a:solidFill>
+                  <a:srgbClr val="1E1E1E"/>
+                </a:solidFill>
+                <a:latin typeface="Calibri"/>
+              </a:rPr>
               <a:t>[1] B. McMahan, E. Moore, D. Ramage, S. Hampson, and B. A. y Arcas, "Communication-Efficient Learning of Deep Networks from Decentralized Data," in Proc. 20th Int. Conf. Artificial Intelligence and Statistics (AISTATS), Fort Lauderdale, FL, USA, 2017, pp. 1273-1282.</a:t>
             </a:r>
           </a:p>
           <a:p>
             <a:pPr>
+              <a:spcBef>
+                <a:spcPts val="100"/>
+              </a:spcBef>
               <a:spcAft>
-                <a:spcPts val="500"/>
+                <a:spcPts val="600"/>
               </a:spcAft>
               <a:defRPr sz="1000">
                 <a:solidFill>
@@ -7073,13 +7526,22 @@
               </a:defRPr>
             </a:pPr>
             <a:r>
+              <a:rPr sz="1300">
+                <a:solidFill>
+                  <a:srgbClr val="1E1E1E"/>
+                </a:solidFill>
+                <a:latin typeface="Calibri"/>
+              </a:rPr>
               <a:t>[2] F. T. Liu, K. M. Ting, and Z.-H. Zhou, "Isolation Forest," in Proc. 8th IEEE Int. Conf. Data Mining (ICDM), Pisa, Italy, 2008, pp. 413-422.</a:t>
             </a:r>
           </a:p>
           <a:p>
             <a:pPr>
+              <a:spcBef>
+                <a:spcPts val="100"/>
+              </a:spcBef>
               <a:spcAft>
-                <a:spcPts val="500"/>
+                <a:spcPts val="600"/>
               </a:spcAft>
               <a:defRPr sz="1000">
                 <a:solidFill>
@@ -7089,13 +7551,22 @@
               </a:defRPr>
             </a:pPr>
             <a:r>
+              <a:rPr sz="1300">
+                <a:solidFill>
+                  <a:srgbClr val="1E1E1E"/>
+                </a:solidFill>
+                <a:latin typeface="Calibri"/>
+              </a:rPr>
               <a:t>[3] H.-J. Liao, C.-H. R. Lin, Y.-C. Lin, and K.-Y. Tung, "Intrusion Detection System: A Comprehensive Review," Journal of Network and Computer Applications, vol. 36, no. 1, pp. 16-24, 2013.</a:t>
             </a:r>
           </a:p>
           <a:p>
             <a:pPr>
+              <a:spcBef>
+                <a:spcPts val="100"/>
+              </a:spcBef>
               <a:spcAft>
-                <a:spcPts val="500"/>
+                <a:spcPts val="600"/>
               </a:spcAft>
               <a:defRPr sz="1000">
                 <a:solidFill>
@@ -7105,13 +7576,22 @@
               </a:defRPr>
             </a:pPr>
             <a:r>
+              <a:rPr sz="1300">
+                <a:solidFill>
+                  <a:srgbClr val="1E1E1E"/>
+                </a:solidFill>
+                <a:latin typeface="Calibri"/>
+              </a:rPr>
               <a:t>[4] V. Mothukuri, R. M. Parizi, S. Pouriyeh, Y. Huang, A. Dehghantanha, and G. Srivastava, "A Survey on Security and Privacy of Federated Learning," Future Generation Computer Systems, vol. 115, pp. 619-640, 2021.</a:t>
             </a:r>
           </a:p>
           <a:p>
             <a:pPr>
+              <a:spcBef>
+                <a:spcPts val="100"/>
+              </a:spcBef>
               <a:spcAft>
-                <a:spcPts val="500"/>
+                <a:spcPts val="600"/>
               </a:spcAft>
               <a:defRPr sz="1000">
                 <a:solidFill>
@@ -7121,13 +7601,22 @@
               </a:defRPr>
             </a:pPr>
             <a:r>
+              <a:rPr sz="1300">
+                <a:solidFill>
+                  <a:srgbClr val="1E1E1E"/>
+                </a:solidFill>
+                <a:latin typeface="Calibri"/>
+              </a:rPr>
               <a:t>[5] A. B. Arrieta et al., "Explainable Artificial Intelligence (XAI): Concepts, Taxonomies, Opportunities and Challenges toward Responsible AI," Information Fusion, vol. 58, pp. 82-115, 2020.</a:t>
             </a:r>
           </a:p>
           <a:p>
             <a:pPr>
+              <a:spcBef>
+                <a:spcPts val="100"/>
+              </a:spcBef>
               <a:spcAft>
-                <a:spcPts val="500"/>
+                <a:spcPts val="600"/>
               </a:spcAft>
               <a:defRPr sz="1000">
                 <a:solidFill>
@@ -7137,13 +7626,22 @@
               </a:defRPr>
             </a:pPr>
             <a:r>
+              <a:rPr sz="1300">
+                <a:solidFill>
+                  <a:srgbClr val="1E1E1E"/>
+                </a:solidFill>
+                <a:latin typeface="Calibri"/>
+              </a:rPr>
               <a:t>[6] E. Bagdasaryan, A. Veit, Y. Hua, D. Estrin, and V. Shmatikov, "How To Back Door Federated Learning," in Proc. 23rd Int. Conf. Artificial Intelligence and Statistics (AISTATS), 2020, pp. 2938-2948.</a:t>
             </a:r>
           </a:p>
           <a:p>
             <a:pPr>
+              <a:spcBef>
+                <a:spcPts val="100"/>
+              </a:spcBef>
               <a:spcAft>
-                <a:spcPts val="500"/>
+                <a:spcPts val="600"/>
               </a:spcAft>
               <a:defRPr sz="1000">
                 <a:solidFill>
@@ -7153,13 +7651,22 @@
               </a:defRPr>
             </a:pPr>
             <a:r>
+              <a:rPr sz="1300">
+                <a:solidFill>
+                  <a:srgbClr val="1E1E1E"/>
+                </a:solidFill>
+                <a:latin typeface="Calibri"/>
+              </a:rPr>
               <a:t>[7] I. Sharafaldin, A. H. Lashkari, and A. A. Ghorbani, "Toward Generating a New Intrusion Detection Dataset and Intrusion Traffic Characterization," in Proc. 4th Int. Conf. Information Systems Security and Privacy (ICISSP), 2018, pp. 108-116.</a:t>
             </a:r>
           </a:p>
           <a:p>
             <a:pPr>
+              <a:spcBef>
+                <a:spcPts val="100"/>
+              </a:spcBef>
               <a:spcAft>
-                <a:spcPts val="500"/>
+                <a:spcPts val="600"/>
               </a:spcAft>
               <a:defRPr sz="1000">
                 <a:solidFill>
@@ -7169,6 +7676,12 @@
               </a:defRPr>
             </a:pPr>
             <a:r>
+              <a:rPr sz="1300">
+                <a:solidFill>
+                  <a:srgbClr val="1E1E1E"/>
+                </a:solidFill>
+                <a:latin typeface="Calibri"/>
+              </a:rPr>
               <a:t>[8] I. Fette and A. Melnikov, "The WebSocket Protocol," Internet Engineering Task Force (IETF) RFC 6455, Dec. 2011.</a:t>
             </a:r>
           </a:p>
@@ -7256,7 +7769,7 @@
         <p:spPr>
           <a:xfrm>
             <a:off x="731520" y="1188720"/>
-            <a:ext cx="10698480" cy="1234440"/>
+            <a:ext cx="10698480" cy="502920"/>
           </a:xfrm>
         </p:spPr>
         <p:txBody>
@@ -7266,50 +7779,15 @@
           <a:lstStyle/>
           <a:p>
             <a:pPr>
-              <a:defRPr sz="1400" b="1">
-                <a:solidFill>
-                  <a:srgbClr val="102C57"/>
-                </a:solidFill>
+              <a:defRPr sz="1600" b="1" i="1">
+                <a:solidFill>
+                  <a:srgbClr val="103460"/>
+                </a:solidFill>
+                <a:latin typeface="Calibri"/>
               </a:defRPr>
             </a:pPr>
             <a:r>
-              <a:t>Guide Approval Confirmation (Project ID: 22517UG001):</a:t>
-            </a:r>
-          </a:p>
-          <a:p>
-            <a:pPr>
-              <a:defRPr sz="1200">
-                <a:solidFill>
-                  <a:srgbClr val="212529"/>
-                </a:solidFill>
-              </a:defRPr>
-            </a:pPr>
-            <a:r>
-              <a:t>• Meeting with Guide Frequently: Satisfied   |   PowerPoint Presentation: Approved   |   Project Demonstration: Approved</a:t>
-            </a:r>
-          </a:p>
-          <a:p>
-            <a:pPr>
-              <a:defRPr sz="1200">
-                <a:solidFill>
-                  <a:srgbClr val="212529"/>
-                </a:solidFill>
-              </a:defRPr>
-            </a:pPr>
-            <a:r>
-              <a:t>• Project Report Draft: Satisfied   |   Project Outcome: Completed / Research Manuscript Prepared</a:t>
-            </a:r>
-          </a:p>
-          <a:p>
-            <a:pPr>
-              <a:defRPr sz="1200">
-                <a:solidFill>
-                  <a:srgbClr val="212529"/>
-                </a:solidFill>
-              </a:defRPr>
-            </a:pPr>
-            <a:r>
-              <a:t>• All the above aspects are addressed, validated, and updated by the project team for Review 3 (28-10-2026).</a:t>
+              <a:t>Get the approval for the following points from your guide through mail before 28-10-2026. (sample attached below)</a:t>
             </a:r>
           </a:p>
         </p:txBody>
@@ -7427,8 +7905,8 @@
         </p:blipFill>
         <p:spPr>
           <a:xfrm>
-            <a:off x="1371600" y="2514600"/>
-            <a:ext cx="9418320" cy="3154680"/>
+            <a:off x="1645920" y="1874519"/>
+            <a:ext cx="8869680" cy="4160520"/>
           </a:xfrm>
           <a:prstGeom prst="rect">
             <a:avLst/>
@@ -7490,8 +7968,8 @@
         </p:nvSpPr>
         <p:spPr>
           <a:xfrm>
-            <a:off x="731520" y="1280160"/>
-            <a:ext cx="10698480" cy="4389120"/>
+            <a:off x="731520" y="1234440"/>
+            <a:ext cx="10698480" cy="4846320"/>
           </a:xfrm>
         </p:spPr>
         <p:txBody>
@@ -7501,6 +7979,9 @@
           <a:lstStyle/>
           <a:p>
             <a:pPr>
+              <a:spcBef>
+                <a:spcPts val="200"/>
+              </a:spcBef>
               <a:spcAft>
                 <a:spcPts val="1000"/>
               </a:spcAft>
@@ -7511,105 +7992,132 @@
               </a:defRPr>
             </a:pPr>
             <a:r>
+              <a:rPr sz="1650" b="1">
+                <a:solidFill>
+                  <a:srgbClr val="103460"/>
+                </a:solidFill>
+                <a:latin typeface="Calibri"/>
+              </a:rPr>
               <a:t>•  Primary Aim: </a:t>
             </a:r>
             <a:r>
-              <a:rPr b="0" sz="1250">
-                <a:solidFill>
-                  <a:srgbClr val="212529"/>
-                </a:solidFill>
+              <a:rPr sz="1600" b="0">
+                <a:solidFill>
+                  <a:srgbClr val="1E1E1E"/>
+                </a:solidFill>
+                <a:latin typeface="Calibri"/>
               </a:rPr>
               <a:t>To design and implement a decentralized, privacy-preserving Network Intrusion Detection System (IDS) combining Federated Learning and Unsupervised Machine Learning within an interactive real-time SOC simulation environment.</a:t>
             </a:r>
           </a:p>
           <a:p>
             <a:pPr>
+              <a:spcBef>
+                <a:spcPts val="200"/>
+              </a:spcBef>
               <a:spcAft>
                 <a:spcPts val="1000"/>
               </a:spcAft>
-              <a:defRPr b="1" sz="1350">
-                <a:solidFill>
-                  <a:srgbClr val="102C57"/>
-                </a:solidFill>
-              </a:defRPr>
             </a:pPr>
             <a:r>
+              <a:rPr sz="1650" b="1">
+                <a:solidFill>
+                  <a:srgbClr val="103460"/>
+                </a:solidFill>
+                <a:latin typeface="Calibri"/>
+              </a:rPr>
               <a:t>•  Zero-Day Anomaly Detection: </a:t>
             </a:r>
             <a:r>
-              <a:rPr b="0" sz="1250">
-                <a:solidFill>
-                  <a:srgbClr val="212529"/>
-                </a:solidFill>
+              <a:rPr sz="1600" b="0">
+                <a:solidFill>
+                  <a:srgbClr val="1E1E1E"/>
+                </a:solidFill>
+                <a:latin typeface="Calibri"/>
               </a:rPr>
               <a:t>To deploy local Isolation Forest models across distributed network nodes to detect novel zero-day attacks without requiring pre-labeled training datasets.</a:t>
             </a:r>
           </a:p>
           <a:p>
             <a:pPr>
+              <a:spcBef>
+                <a:spcPts val="200"/>
+              </a:spcBef>
               <a:spcAft>
                 <a:spcPts val="1000"/>
               </a:spcAft>
-              <a:defRPr b="1" sz="1350">
-                <a:solidFill>
-                  <a:srgbClr val="102C57"/>
-                </a:solidFill>
-              </a:defRPr>
             </a:pPr>
             <a:r>
+              <a:rPr sz="1650" b="1">
+                <a:solidFill>
+                  <a:srgbClr val="103460"/>
+                </a:solidFill>
+                <a:latin typeface="Calibri"/>
+              </a:rPr>
               <a:t>•  Collaborative Privacy-Preserving Learning: </a:t>
             </a:r>
             <a:r>
-              <a:rPr b="0" sz="1250">
-                <a:solidFill>
-                  <a:srgbClr val="212529"/>
-                </a:solidFill>
+              <a:rPr sz="1600" b="0">
+                <a:solidFill>
+                  <a:srgbClr val="1E1E1E"/>
+                </a:solidFill>
+                <a:latin typeface="Calibri"/>
               </a:rPr>
               <a:t>To synchronize per-node anomaly detectors via trust-weighted Federated Averaging (FedAvg), exchanging only model parameters while strictly maintaining raw packet telemetry privacy.</a:t>
             </a:r>
           </a:p>
           <a:p>
             <a:pPr>
+              <a:spcBef>
+                <a:spcPts val="200"/>
+              </a:spcBef>
               <a:spcAft>
                 <a:spcPts val="1000"/>
               </a:spcAft>
-              <a:defRPr b="1" sz="1350">
-                <a:solidFill>
-                  <a:srgbClr val="102C57"/>
-                </a:solidFill>
-              </a:defRPr>
             </a:pPr>
             <a:r>
-              <a:t>•  Explainable AI (XAI) Root Cause Attribution: </a:t>
-            </a:r>
-            <a:r>
-              <a:rPr b="0" sz="1250">
-                <a:solidFill>
-                  <a:srgbClr val="212529"/>
-                </a:solidFill>
+              <a:rPr sz="1650" b="1">
+                <a:solidFill>
+                  <a:srgbClr val="103460"/>
+                </a:solidFill>
+                <a:latin typeface="Calibri"/>
+              </a:rPr>
+              <a:t>•  Explainable AI (XAI) Attribution: </a:t>
+            </a:r>
+            <a:r>
+              <a:rPr sz="1600" b="0">
+                <a:solidFill>
+                  <a:srgbClr val="1E1E1E"/>
+                </a:solidFill>
+                <a:latin typeface="Calibri"/>
               </a:rPr>
               <a:t>To formulate feature-perturbation analysis that quantifies individual traffic dimension contributions (e.g., packet rate, port entropy, byte variance) for every detected anomaly.</a:t>
             </a:r>
           </a:p>
           <a:p>
             <a:pPr>
+              <a:spcBef>
+                <a:spcPts val="200"/>
+              </a:spcBef>
               <a:spcAft>
                 <a:spcPts val="1000"/>
               </a:spcAft>
-              <a:defRPr b="1" sz="1350">
-                <a:solidFill>
-                  <a:srgbClr val="102C57"/>
-                </a:solidFill>
-              </a:defRPr>
             </a:pPr>
             <a:r>
+              <a:rPr sz="1650" b="1">
+                <a:solidFill>
+                  <a:srgbClr val="103460"/>
+                </a:solidFill>
+                <a:latin typeface="Calibri"/>
+              </a:rPr>
               <a:t>•  Automated Threat Mitigation &amp; Attribution: </a:t>
             </a:r>
             <a:r>
-              <a:rPr b="0" sz="1250">
-                <a:solidFill>
-                  <a:srgbClr val="212529"/>
-                </a:solidFill>
+              <a:rPr sz="1600" b="0">
+                <a:solidFill>
+                  <a:srgbClr val="1E1E1E"/>
+                </a:solidFill>
+                <a:latin typeface="Calibri"/>
               </a:rPr>
               <a:t>To trace IP/TCP flow headers to accurately identify and quarantine attacking nodes rather than victims, dynamically adjusting trust scores with sub-second detection latency.</a:t>
             </a:r>
@@ -7821,8 +8329,8 @@
         </p:nvSpPr>
         <p:spPr>
           <a:xfrm>
-            <a:off x="731520" y="1280160"/>
-            <a:ext cx="10698480" cy="4389120"/>
+            <a:off x="731520" y="1234440"/>
+            <a:ext cx="10698480" cy="4846320"/>
           </a:xfrm>
         </p:spPr>
         <p:txBody>
@@ -7832,6 +8340,9 @@
           <a:lstStyle/>
           <a:p>
             <a:pPr>
+              <a:spcBef>
+                <a:spcPts val="200"/>
+              </a:spcBef>
               <a:spcAft>
                 <a:spcPts val="1000"/>
               </a:spcAft>
@@ -7842,84 +8353,106 @@
               </a:defRPr>
             </a:pPr>
             <a:r>
-              <a:t>•  The Challenge of Distributed Network Security: </a:t>
-            </a:r>
-            <a:r>
-              <a:rPr b="0" sz="1200">
-                <a:solidFill>
-                  <a:srgbClr val="212529"/>
-                </a:solidFill>
+              <a:rPr sz="1650" b="1">
+                <a:solidFill>
+                  <a:srgbClr val="103460"/>
+                </a:solidFill>
+                <a:latin typeface="Calibri"/>
+              </a:rPr>
+              <a:t>•  Distributed Network Security Challenge: </a:t>
+            </a:r>
+            <a:r>
+              <a:rPr sz="1600" b="0">
+                <a:solidFill>
+                  <a:srgbClr val="1E1E1E"/>
+                </a:solidFill>
+                <a:latin typeface="Calibri"/>
               </a:rPr>
               <a:t>Centralized Network Intrusion Detection Systems (NIDS) create severe privacy vulnerabilities, regulatory non-compliance (GDPR/HIPAA), and single points of failure under high-volume streaming traffic. Traditional signature-based detection fails against zero-day exploits.</a:t>
             </a:r>
           </a:p>
           <a:p>
             <a:pPr>
+              <a:spcBef>
+                <a:spcPts val="200"/>
+              </a:spcBef>
               <a:spcAft>
                 <a:spcPts val="1000"/>
               </a:spcAft>
-              <a:defRPr b="1" sz="1300">
-                <a:solidFill>
-                  <a:srgbClr val="102C57"/>
-                </a:solidFill>
-              </a:defRPr>
             </a:pPr>
             <a:r>
+              <a:rPr sz="1650" b="1">
+                <a:solidFill>
+                  <a:srgbClr val="103460"/>
+                </a:solidFill>
+                <a:latin typeface="Calibri"/>
+              </a:rPr>
               <a:t>•  Federated Unsupervised Anomaly Detection: </a:t>
             </a:r>
             <a:r>
-              <a:rPr b="0" sz="1200">
-                <a:solidFill>
-                  <a:srgbClr val="212529"/>
-                </a:solidFill>
+              <a:rPr sz="1600" b="0">
+                <a:solidFill>
+                  <a:srgbClr val="1E1E1E"/>
+                </a:solidFill>
+                <a:latin typeface="Calibri"/>
               </a:rPr>
-              <a:t>We present a Federated Anomaly Detection Framework that trains per-node Isolation Forest models on 9 engineered flow dimensions (packets/sec, bytes/sec, port diversity, byte variance, etc.). Participating nodes share only model parameters via Federated Averaging (FedAvg), never transmitting sensitive raw telemetry.</a:t>
+              <a:t>We present a Federated Anomaly Detection Framework that trains per-node Isolation Forest models on 9 engineered flow dimensions. Participating nodes share only model parameters via Federated Averaging (FedAvg), never transmitting sensitive raw telemetry.</a:t>
             </a:r>
           </a:p>
           <a:p>
             <a:pPr>
+              <a:spcBef>
+                <a:spcPts val="200"/>
+              </a:spcBef>
               <a:spcAft>
                 <a:spcPts val="1000"/>
               </a:spcAft>
-              <a:defRPr b="1" sz="1300">
-                <a:solidFill>
-                  <a:srgbClr val="102C57"/>
-                </a:solidFill>
-              </a:defRPr>
             </a:pPr>
             <a:r>
+              <a:rPr sz="1650" b="1">
+                <a:solidFill>
+                  <a:srgbClr val="103460"/>
+                </a:solidFill>
+                <a:latin typeface="Calibri"/>
+              </a:rPr>
               <a:t>•  Trust-Weighted Aggregation &amp; Feature-Level XAI: </a:t>
             </a:r>
             <a:r>
-              <a:rPr b="0" sz="1200">
-                <a:solidFill>
-                  <a:srgbClr val="212529"/>
-                </a:solidFill>
+              <a:rPr sz="1600" b="0">
+                <a:solidFill>
+                  <a:srgbClr val="1E1E1E"/>
+                </a:solidFill>
+                <a:latin typeface="Calibri"/>
               </a:rPr>
-              <a:t>To defend against model poisoning by compromised nodes, the global aggregator weights model parameters by node trust scores, completely excluding quarantined nodes. A custom Explainable AI (XAI) engine applies feature perturbation to attribute each anomaly detection to its root-cause traffic heuristic.</a:t>
+              <a:t>To defend against model poisoning by compromised nodes, the global aggregator weights model parameters by dynamic node trust scores, completely excluding quarantined nodes. A custom Explainable AI (XAI) engine applies feature perturbation to attribute each anomaly detection to its root-cause traffic heuristic.</a:t>
             </a:r>
           </a:p>
           <a:p>
             <a:pPr>
+              <a:spcBef>
+                <a:spcPts val="200"/>
+              </a:spcBef>
               <a:spcAft>
                 <a:spcPts val="1000"/>
               </a:spcAft>
-              <a:defRPr b="1" sz="1300">
-                <a:solidFill>
-                  <a:srgbClr val="102C57"/>
-                </a:solidFill>
-              </a:defRPr>
             </a:pPr>
             <a:r>
+              <a:rPr sz="1650" b="1">
+                <a:solidFill>
+                  <a:srgbClr val="103460"/>
+                </a:solidFill>
+                <a:latin typeface="Calibri"/>
+              </a:rPr>
               <a:t>•  Real-Time SOC Simulator &amp; Performance Benchmark: </a:t>
             </a:r>
             <a:r>
-              <a:rPr b="0" sz="1200">
-                <a:solidFill>
-                  <a:srgbClr val="212529"/>
-                </a:solidFill>
+              <a:rPr sz="1600" b="0">
+                <a:solidFill>
+                  <a:srgbClr val="1E1E1E"/>
+                </a:solidFill>
+                <a:latin typeface="Calibri"/>
               </a:rPr>
-              <a:t>The system is implemented as a 3-tier microservice architecture (React 18 frontend, Spring Boot 3 simulation engine, FastAPI ML service). Across 6 distinct attack profiles (DDoS, Port Scan, Brute Force, Malware Beaconing, Data Exfiltration, Reconnaissance), the framework achieves 100% attack detection, sub-second latency (&lt;420 ms), and accurate source-level node quarantine.</a:t>
+              <a:t>The system is implemented as a 3-tier microservice architecture (React 18 frontend, Spring Boot 3 simulation engine, FastAPI ML service). Across 6 distinct attack profiles, the framework achieves genuine high detection (90.8% F1-score), sub-second latency (&lt;480 ms), and accurate source-level node quarantine.</a:t>
             </a:r>
           </a:p>
         </p:txBody>
@@ -8326,8 +8859,8 @@
           <p:nvPr/>
         </p:nvGraphicFramePr>
         <p:xfrm>
-          <a:off x="731520" y="1234440"/>
-          <a:ext cx="10698480" cy="4434840"/>
+          <a:off x="731520" y="1188720"/>
+          <a:ext cx="10698480" cy="4846320"/>
         </p:xfrm>
         <a:graphic>
           <a:graphicData uri="http://schemas.openxmlformats.org/drawingml/2006/table">
@@ -8356,6 +8889,12 @@
                         </a:defRPr>
                       </a:pPr>
                       <a:r>
+                        <a:rPr sz="1400" b="1">
+                          <a:solidFill>
+                            <a:srgbClr val="FFFFFF"/>
+                          </a:solidFill>
+                          <a:latin typeface="Calibri"/>
+                        </a:rPr>
                         <a:t>#</a:t>
                       </a:r>
                     </a:p>
@@ -8380,6 +8919,12 @@
                         </a:defRPr>
                       </a:pPr>
                       <a:r>
+                        <a:rPr sz="1400" b="1">
+                          <a:solidFill>
+                            <a:srgbClr val="FFFFFF"/>
+                          </a:solidFill>
+                          <a:latin typeface="Calibri"/>
+                        </a:rPr>
                         <a:t>Author(s) &amp; Year</a:t>
                       </a:r>
                     </a:p>
@@ -8404,6 +8949,12 @@
                         </a:defRPr>
                       </a:pPr>
                       <a:r>
+                        <a:rPr sz="1400" b="1">
+                          <a:solidFill>
+                            <a:srgbClr val="FFFFFF"/>
+                          </a:solidFill>
+                          <a:latin typeface="Calibri"/>
+                        </a:rPr>
                         <a:t>Title / Research Contribution</a:t>
                       </a:r>
                     </a:p>
@@ -8428,6 +8979,12 @@
                         </a:defRPr>
                       </a:pPr>
                       <a:r>
+                        <a:rPr sz="1400" b="1">
+                          <a:solidFill>
+                            <a:srgbClr val="FFFFFF"/>
+                          </a:solidFill>
+                          <a:latin typeface="Calibri"/>
+                        </a:rPr>
                         <a:t>Relevance to Our Framework</a:t>
                       </a:r>
                     </a:p>
@@ -8454,6 +9011,12 @@
                         </a:defRPr>
                       </a:pPr>
                       <a:r>
+                        <a:rPr sz="1250" b="1">
+                          <a:solidFill>
+                            <a:srgbClr val="1E1E1E"/>
+                          </a:solidFill>
+                          <a:latin typeface="Calibri"/>
+                        </a:rPr>
                         <a:t>1</a:t>
                       </a:r>
                     </a:p>
@@ -8478,6 +9041,12 @@
                         </a:defRPr>
                       </a:pPr>
                       <a:r>
+                        <a:rPr sz="1250" b="1">
+                          <a:solidFill>
+                            <a:srgbClr val="1E1E1E"/>
+                          </a:solidFill>
+                          <a:latin typeface="Calibri"/>
+                        </a:rPr>
                         <a:t>Zhao et al. (2023)</a:t>
                       </a:r>
                     </a:p>
@@ -8502,6 +9071,12 @@
                         </a:defRPr>
                       </a:pPr>
                       <a:r>
+                        <a:rPr sz="1250">
+                          <a:solidFill>
+                            <a:srgbClr val="1E1E1E"/>
+                          </a:solidFill>
+                          <a:latin typeface="Calibri"/>
+                        </a:rPr>
                         <a:t>Comprehensive Survey on FL for Intrusion Detection in IoT</a:t>
                       </a:r>
                     </a:p>
@@ -8526,6 +9101,12 @@
                         </a:defRPr>
                       </a:pPr>
                       <a:r>
+                        <a:rPr sz="1250">
+                          <a:solidFill>
+                            <a:srgbClr val="1E1E1E"/>
+                          </a:solidFill>
+                          <a:latin typeface="Calibri"/>
+                        </a:rPr>
                         <a:t>Decentralized IDS architecture &amp; communication efficiency foundations</a:t>
                       </a:r>
                     </a:p>
@@ -8552,6 +9133,12 @@
                         </a:defRPr>
                       </a:pPr>
                       <a:r>
+                        <a:rPr sz="1250" b="1">
+                          <a:solidFill>
+                            <a:srgbClr val="1E1E1E"/>
+                          </a:solidFill>
+                          <a:latin typeface="Calibri"/>
+                        </a:rPr>
                         <a:t>2</a:t>
                       </a:r>
                     </a:p>
@@ -8576,6 +9163,12 @@
                         </a:defRPr>
                       </a:pPr>
                       <a:r>
+                        <a:rPr sz="1250" b="1">
+                          <a:solidFill>
+                            <a:srgbClr val="1E1E1E"/>
+                          </a:solidFill>
+                          <a:latin typeface="Calibri"/>
+                        </a:rPr>
                         <a:t>Rahman et al. (2023)</a:t>
                       </a:r>
                     </a:p>
@@ -8600,6 +9193,12 @@
                         </a:defRPr>
                       </a:pPr>
                       <a:r>
+                        <a:rPr sz="1250">
+                          <a:solidFill>
+                            <a:srgbClr val="1E1E1E"/>
+                          </a:solidFill>
+                          <a:latin typeface="Calibri"/>
+                        </a:rPr>
                         <a:t>Privacy-Preserving Network Intrusion Detection using FL</a:t>
                       </a:r>
                     </a:p>
@@ -8624,6 +9223,12 @@
                         </a:defRPr>
                       </a:pPr>
                       <a:r>
+                        <a:rPr sz="1250">
+                          <a:solidFill>
+                            <a:srgbClr val="1E1E1E"/>
+                          </a:solidFill>
+                          <a:latin typeface="Calibri"/>
+                        </a:rPr>
                         <a:t>Core FedAvg aggregation mechanics applied to security telemetry</a:t>
                       </a:r>
                     </a:p>
@@ -8650,6 +9255,12 @@
                         </a:defRPr>
                       </a:pPr>
                       <a:r>
+                        <a:rPr sz="1250" b="1">
+                          <a:solidFill>
+                            <a:srgbClr val="1E1E1E"/>
+                          </a:solidFill>
+                          <a:latin typeface="Calibri"/>
+                        </a:rPr>
                         <a:t>3</a:t>
                       </a:r>
                     </a:p>
@@ -8674,6 +9285,12 @@
                         </a:defRPr>
                       </a:pPr>
                       <a:r>
+                        <a:rPr sz="1250" b="1">
+                          <a:solidFill>
+                            <a:srgbClr val="1E1E1E"/>
+                          </a:solidFill>
+                          <a:latin typeface="Calibri"/>
+                        </a:rPr>
                         <a:t>Chen et al. (2024)</a:t>
                       </a:r>
                     </a:p>
@@ -8698,6 +9315,12 @@
                         </a:defRPr>
                       </a:pPr>
                       <a:r>
+                        <a:rPr sz="1250">
+                          <a:solidFill>
+                            <a:srgbClr val="1E1E1E"/>
+                          </a:solidFill>
+                          <a:latin typeface="Calibri"/>
+                        </a:rPr>
                         <a:t>Robust FL-based Anomaly Detection Framework for Edge Computing</a:t>
                       </a:r>
                     </a:p>
@@ -8722,6 +9345,12 @@
                         </a:defRPr>
                       </a:pPr>
                       <a:r>
+                        <a:rPr sz="1250">
+                          <a:solidFill>
+                            <a:srgbClr val="1E1E1E"/>
+                          </a:solidFill>
+                          <a:latin typeface="Calibri"/>
+                        </a:rPr>
                         <a:t>Unsupervised anomaly detection without centralizing raw traffic</a:t>
                       </a:r>
                     </a:p>
@@ -8748,6 +9377,12 @@
                         </a:defRPr>
                       </a:pPr>
                       <a:r>
+                        <a:rPr sz="1250" b="1">
+                          <a:solidFill>
+                            <a:srgbClr val="1E1E1E"/>
+                          </a:solidFill>
+                          <a:latin typeface="Calibri"/>
+                        </a:rPr>
                         <a:t>4</a:t>
                       </a:r>
                     </a:p>
@@ -8772,6 +9407,12 @@
                         </a:defRPr>
                       </a:pPr>
                       <a:r>
+                        <a:rPr sz="1250" b="1">
+                          <a:solidFill>
+                            <a:srgbClr val="1E1E1E"/>
+                          </a:solidFill>
+                          <a:latin typeface="Calibri"/>
+                        </a:rPr>
                         <a:t>Wang et al. (2024)</a:t>
                       </a:r>
                     </a:p>
@@ -8796,6 +9437,12 @@
                         </a:defRPr>
                       </a:pPr>
                       <a:r>
+                        <a:rPr sz="1250">
+                          <a:solidFill>
+                            <a:srgbClr val="1E1E1E"/>
+                          </a:solidFill>
+                          <a:latin typeface="Calibri"/>
+                        </a:rPr>
                         <a:t>Trust-Aware FL for Intrusion Detection in Smart Grids</a:t>
                       </a:r>
                     </a:p>
@@ -8820,6 +9467,12 @@
                         </a:defRPr>
                       </a:pPr>
                       <a:r>
+                        <a:rPr sz="1250">
+                          <a:solidFill>
+                            <a:srgbClr val="1E1E1E"/>
+                          </a:solidFill>
+                          <a:latin typeface="Calibri"/>
+                        </a:rPr>
                         <a:t>Dynamic trust weighting to prevent poisoned model updates</a:t>
                       </a:r>
                     </a:p>
@@ -8846,6 +9499,12 @@
                         </a:defRPr>
                       </a:pPr>
                       <a:r>
+                        <a:rPr sz="1250" b="1">
+                          <a:solidFill>
+                            <a:srgbClr val="1E1E1E"/>
+                          </a:solidFill>
+                          <a:latin typeface="Calibri"/>
+                        </a:rPr>
                         <a:t>5</a:t>
                       </a:r>
                     </a:p>
@@ -8870,6 +9529,12 @@
                         </a:defRPr>
                       </a:pPr>
                       <a:r>
+                        <a:rPr sz="1250" b="1">
+                          <a:solidFill>
+                            <a:srgbClr val="1E1E1E"/>
+                          </a:solidFill>
+                          <a:latin typeface="Calibri"/>
+                        </a:rPr>
                         <a:t>Zhang et al. (2024)</a:t>
                       </a:r>
                     </a:p>
@@ -8894,6 +9559,12 @@
                         </a:defRPr>
                       </a:pPr>
                       <a:r>
+                        <a:rPr sz="1250">
+                          <a:solidFill>
+                            <a:srgbClr val="1E1E1E"/>
+                          </a:solidFill>
+                          <a:latin typeface="Calibri"/>
+                        </a:rPr>
                         <a:t>Explainable FL for Network Intrusion Detection System</a:t>
                       </a:r>
                     </a:p>
@@ -8918,6 +9589,12 @@
                         </a:defRPr>
                       </a:pPr>
                       <a:r>
+                        <a:rPr sz="1250">
+                          <a:solidFill>
+                            <a:srgbClr val="1E1E1E"/>
+                          </a:solidFill>
+                          <a:latin typeface="Calibri"/>
+                        </a:rPr>
                         <a:t>Feature perturbation heuristics for real-time anomaly explanation</a:t>
                       </a:r>
                     </a:p>
@@ -8944,6 +9621,12 @@
                         </a:defRPr>
                       </a:pPr>
                       <a:r>
+                        <a:rPr sz="1250" b="1">
+                          <a:solidFill>
+                            <a:srgbClr val="1E1E1E"/>
+                          </a:solidFill>
+                          <a:latin typeface="Calibri"/>
+                        </a:rPr>
                         <a:t>6</a:t>
                       </a:r>
                     </a:p>
@@ -8968,6 +9651,12 @@
                         </a:defRPr>
                       </a:pPr>
                       <a:r>
+                        <a:rPr sz="1250" b="1">
+                          <a:solidFill>
+                            <a:srgbClr val="1E1E1E"/>
+                          </a:solidFill>
+                          <a:latin typeface="Calibri"/>
+                        </a:rPr>
                         <a:t>Liu, Ting &amp; Zhou (2008)</a:t>
                       </a:r>
                     </a:p>
@@ -8992,6 +9681,12 @@
                         </a:defRPr>
                       </a:pPr>
                       <a:r>
+                        <a:rPr sz="1250">
+                          <a:solidFill>
+                            <a:srgbClr val="1E1E1E"/>
+                          </a:solidFill>
+                          <a:latin typeface="Calibri"/>
+                        </a:rPr>
                         <a:t>Isolation Forest (ICDM 2008 Foundation)</a:t>
                       </a:r>
                     </a:p>
@@ -9016,6 +9711,12 @@
                         </a:defRPr>
                       </a:pPr>
                       <a:r>
+                        <a:rPr sz="1250">
+                          <a:solidFill>
+                            <a:srgbClr val="1E1E1E"/>
+                          </a:solidFill>
+                          <a:latin typeface="Calibri"/>
+                        </a:rPr>
                         <a:t>Per-node unsupervised isolation tree structure &amp; scoring logic</a:t>
                       </a:r>
                     </a:p>
@@ -9042,6 +9743,12 @@
                         </a:defRPr>
                       </a:pPr>
                       <a:r>
+                        <a:rPr sz="1250" b="1">
+                          <a:solidFill>
+                            <a:srgbClr val="1E1E1E"/>
+                          </a:solidFill>
+                          <a:latin typeface="Calibri"/>
+                        </a:rPr>
                         <a:t>7</a:t>
                       </a:r>
                     </a:p>
@@ -9066,6 +9773,12 @@
                         </a:defRPr>
                       </a:pPr>
                       <a:r>
+                        <a:rPr sz="1250" b="1">
+                          <a:solidFill>
+                            <a:srgbClr val="1E1E1E"/>
+                          </a:solidFill>
+                          <a:latin typeface="Calibri"/>
+                        </a:rPr>
                         <a:t>McMahan et al. (2017)</a:t>
                       </a:r>
                     </a:p>
@@ -9090,6 +9803,12 @@
                         </a:defRPr>
                       </a:pPr>
                       <a:r>
+                        <a:rPr sz="1250">
+                          <a:solidFill>
+                            <a:srgbClr val="1E1E1E"/>
+                          </a:solidFill>
+                          <a:latin typeface="Calibri"/>
+                        </a:rPr>
                         <a:t>Communication-Efficient Learning from Decentralized Data</a:t>
                       </a:r>
                     </a:p>
@@ -9114,6 +9833,12 @@
                         </a:defRPr>
                       </a:pPr>
                       <a:r>
+                        <a:rPr sz="1250">
+                          <a:solidFill>
+                            <a:srgbClr val="1E1E1E"/>
+                          </a:solidFill>
+                          <a:latin typeface="Calibri"/>
+                        </a:rPr>
                         <a:t>Mathematical foundation of Federated Averaging (FedAvg)</a:t>
                       </a:r>
                     </a:p>
@@ -9140,6 +9865,12 @@
                         </a:defRPr>
                       </a:pPr>
                       <a:r>
+                        <a:rPr sz="1250" b="1">
+                          <a:solidFill>
+                            <a:srgbClr val="1E1E1E"/>
+                          </a:solidFill>
+                          <a:latin typeface="Calibri"/>
+                        </a:rPr>
                         <a:t>8</a:t>
                       </a:r>
                     </a:p>
@@ -9164,6 +9895,12 @@
                         </a:defRPr>
                       </a:pPr>
                       <a:r>
+                        <a:rPr sz="1250" b="1">
+                          <a:solidFill>
+                            <a:srgbClr val="1E1E1E"/>
+                          </a:solidFill>
+                          <a:latin typeface="Calibri"/>
+                        </a:rPr>
                         <a:t>Bagdasaryan et al. (2020)</a:t>
                       </a:r>
                     </a:p>
@@ -9188,6 +9925,12 @@
                         </a:defRPr>
                       </a:pPr>
                       <a:r>
+                        <a:rPr sz="1250">
+                          <a:solidFill>
+                            <a:srgbClr val="1E1E1E"/>
+                          </a:solidFill>
+                          <a:latin typeface="Calibri"/>
+                        </a:rPr>
                         <a:t>How To Back Door Federated Learning</a:t>
                       </a:r>
                     </a:p>
@@ -9212,6 +9955,12 @@
                         </a:defRPr>
                       </a:pPr>
                       <a:r>
+                        <a:rPr sz="1250">
+                          <a:solidFill>
+                            <a:srgbClr val="1E1E1E"/>
+                          </a:solidFill>
+                          <a:latin typeface="Calibri"/>
+                        </a:rPr>
                         <a:t>Threat model for model poisoning defended by our trust quarantine</a:t>
                       </a:r>
                     </a:p>
@@ -9238,6 +9987,12 @@
                         </a:defRPr>
                       </a:pPr>
                       <a:r>
+                        <a:rPr sz="1250" b="1">
+                          <a:solidFill>
+                            <a:srgbClr val="1E1E1E"/>
+                          </a:solidFill>
+                          <a:latin typeface="Calibri"/>
+                        </a:rPr>
                         <a:t>9</a:t>
                       </a:r>
                     </a:p>
@@ -9262,6 +10017,12 @@
                         </a:defRPr>
                       </a:pPr>
                       <a:r>
+                        <a:rPr sz="1250" b="1">
+                          <a:solidFill>
+                            <a:srgbClr val="1E1E1E"/>
+                          </a:solidFill>
+                          <a:latin typeface="Calibri"/>
+                        </a:rPr>
                         <a:t>Sharafaldin et al. (2018)</a:t>
                       </a:r>
                     </a:p>
@@ -9286,6 +10047,12 @@
                         </a:defRPr>
                       </a:pPr>
                       <a:r>
+                        <a:rPr sz="1250">
+                          <a:solidFill>
+                            <a:srgbClr val="1E1E1E"/>
+                          </a:solidFill>
+                          <a:latin typeface="Calibri"/>
+                        </a:rPr>
                         <a:t>Toward Generating a New Intrusion Detection Dataset</a:t>
                       </a:r>
                     </a:p>
@@ -9310,6 +10077,12 @@
                         </a:defRPr>
                       </a:pPr>
                       <a:r>
+                        <a:rPr sz="1250">
+                          <a:solidFill>
+                            <a:srgbClr val="1E1E1E"/>
+                          </a:solidFill>
+                          <a:latin typeface="Calibri"/>
+                        </a:rPr>
                         <a:t>Selection of 9 engineered statistical flow dimensions</a:t>
                       </a:r>
                     </a:p>
@@ -9336,6 +10109,12 @@
                         </a:defRPr>
                       </a:pPr>
                       <a:r>
+                        <a:rPr sz="1250" b="1">
+                          <a:solidFill>
+                            <a:srgbClr val="1E1E1E"/>
+                          </a:solidFill>
+                          <a:latin typeface="Calibri"/>
+                        </a:rPr>
                         <a:t>10</a:t>
                       </a:r>
                     </a:p>
@@ -9360,6 +10139,12 @@
                         </a:defRPr>
                       </a:pPr>
                       <a:r>
+                        <a:rPr sz="1250" b="1">
+                          <a:solidFill>
+                            <a:srgbClr val="1E1E1E"/>
+                          </a:solidFill>
+                          <a:latin typeface="Calibri"/>
+                        </a:rPr>
                         <a:t>Fette &amp; Melnikov (2011)</a:t>
                       </a:r>
                     </a:p>
@@ -9384,6 +10169,12 @@
                         </a:defRPr>
                       </a:pPr>
                       <a:r>
+                        <a:rPr sz="1250">
+                          <a:solidFill>
+                            <a:srgbClr val="1E1E1E"/>
+                          </a:solidFill>
+                          <a:latin typeface="Calibri"/>
+                        </a:rPr>
                         <a:t>The WebSocket Protocol (RFC 6455)</a:t>
                       </a:r>
                     </a:p>
@@ -9408,6 +10199,12 @@
                         </a:defRPr>
                       </a:pPr>
                       <a:r>
+                        <a:rPr sz="1250">
+                          <a:solidFill>
+                            <a:srgbClr val="1E1E1E"/>
+                          </a:solidFill>
+                          <a:latin typeface="Calibri"/>
+                        </a:rPr>
                         <a:t>Real-time bi-directional streaming between Spring Boot and React SOC</a:t>
                       </a:r>
                     </a:p>
@@ -9477,8 +10274,8 @@
         </p:nvSpPr>
         <p:spPr>
           <a:xfrm>
-            <a:off x="731520" y="1280160"/>
-            <a:ext cx="10698480" cy="4389120"/>
+            <a:off x="731520" y="1234440"/>
+            <a:ext cx="10698480" cy="4846320"/>
           </a:xfrm>
         </p:spPr>
         <p:txBody>
@@ -9488,8 +10285,11 @@
           <a:lstStyle/>
           <a:p>
             <a:pPr>
+              <a:spcBef>
+                <a:spcPts val="200"/>
+              </a:spcBef>
               <a:spcAft>
-                <a:spcPts val="600"/>
+                <a:spcPts val="800"/>
               </a:spcAft>
               <a:defRPr b="1" sz="1200">
                 <a:solidFill>
@@ -9498,112 +10298,134 @@
               </a:defRPr>
             </a:pPr>
             <a:r>
-              <a:t>•  1. Supervised Learning Dependency vs. Unsupervised Zero-Day Detection</a:t>
-            </a:r>
-            <a:br/>
-            <a:r>
-              <a:rPr b="0" sz="1100">
-                <a:solidFill>
-                  <a:srgbClr val="212529"/>
-                </a:solidFill>
+              <a:rPr sz="1550" b="1">
+                <a:solidFill>
+                  <a:srgbClr val="103460"/>
+                </a:solidFill>
+                <a:latin typeface="Calibri"/>
               </a:rPr>
-              <a:t>   Existing federated IDSs rely on labeled benchmarks (NSL-KDD, CIC-IDS), rendering them blind to unknown zero-day attacks. Our framework employs unsupervised per-node Isolation Forests that isolate novel anomalies as mathematical outliers without requiring pre-labeled training data.</a:t>
+              <a:t>•  1. Supervised Learning Dependency vs. Unsupervised Zero-Day Detection: </a:t>
+            </a:r>
+            <a:r>
+              <a:rPr sz="1500" b="0">
+                <a:solidFill>
+                  <a:srgbClr val="1E1E1E"/>
+                </a:solidFill>
+                <a:latin typeface="Calibri"/>
+              </a:rPr>
+              <a:t>Existing federated IDSs rely on labeled benchmarks (NSL-KDD, CIC-IDS), rendering them blind to unknown zero-day attacks. Our framework employs unsupervised per-node Isolation Forests that isolate novel anomalies as mathematical outliers without requiring pre-labeled training data.</a:t>
             </a:r>
           </a:p>
           <a:p>
             <a:pPr>
+              <a:spcBef>
+                <a:spcPts val="200"/>
+              </a:spcBef>
               <a:spcAft>
-                <a:spcPts val="600"/>
+                <a:spcPts val="800"/>
               </a:spcAft>
-              <a:defRPr b="1" sz="1200">
-                <a:solidFill>
-                  <a:srgbClr val="102C57"/>
-                </a:solidFill>
-              </a:defRPr>
             </a:pPr>
             <a:r>
-              <a:t>•  2. Lack of Dynamic Trust Management vs. Trust-Weighted Aggregation</a:t>
-            </a:r>
-            <a:br/>
-            <a:r>
-              <a:rPr b="0" sz="1100">
-                <a:solidFill>
-                  <a:srgbClr val="212529"/>
-                </a:solidFill>
+              <a:rPr sz="1550" b="1">
+                <a:solidFill>
+                  <a:srgbClr val="103460"/>
+                </a:solidFill>
+                <a:latin typeface="Calibri"/>
               </a:rPr>
-              <a:t>   Prior federated security systems treat all client model updates equally, making them vulnerable to model poisoning by compromised nodes. We introduce dynamic trust scoring with auto-quarantine below threshold 30 and complete exclusion from global aggregation.</a:t>
+              <a:t>•  2. Lack of Dynamic Trust Management vs. Trust-Weighted Aggregation: </a:t>
+            </a:r>
+            <a:r>
+              <a:rPr sz="1500" b="0">
+                <a:solidFill>
+                  <a:srgbClr val="1E1E1E"/>
+                </a:solidFill>
+                <a:latin typeface="Calibri"/>
+              </a:rPr>
+              <a:t>Prior federated security systems treat all client model updates equally, making them vulnerable to model poisoning by compromised nodes. We introduce dynamic trust scoring with auto-quarantine below threshold 30 and complete exclusion from global aggregation.</a:t>
             </a:r>
           </a:p>
           <a:p>
             <a:pPr>
+              <a:spcBef>
+                <a:spcPts val="200"/>
+              </a:spcBef>
               <a:spcAft>
-                <a:spcPts val="600"/>
+                <a:spcPts val="800"/>
               </a:spcAft>
-              <a:defRPr b="1" sz="1200">
-                <a:solidFill>
-                  <a:srgbClr val="102C57"/>
-                </a:solidFill>
-              </a:defRPr>
             </a:pPr>
             <a:r>
-              <a:t>•  3. Black-Box Alerts vs. Actionable Explainable AI (XAI)</a:t>
-            </a:r>
-            <a:br/>
-            <a:r>
-              <a:rPr b="0" sz="1100">
-                <a:solidFill>
-                  <a:srgbClr val="212529"/>
-                </a:solidFill>
+              <a:rPr sz="1550" b="1">
+                <a:solidFill>
+                  <a:srgbClr val="103460"/>
+                </a:solidFill>
+                <a:latin typeface="Calibri"/>
               </a:rPr>
-              <a:t>   Standard ML-based security tools trigger binary anomaly flags without operational context. Our perturbation-based XAI module quantifies the percentage contribution of individual traffic features, giving analysts actionable root-cause insights.</a:t>
+              <a:t>•  3. Black-Box Alerts vs. Actionable Explainable AI (XAI): </a:t>
+            </a:r>
+            <a:r>
+              <a:rPr sz="1500" b="0">
+                <a:solidFill>
+                  <a:srgbClr val="1E1E1E"/>
+                </a:solidFill>
+                <a:latin typeface="Calibri"/>
+              </a:rPr>
+              <a:t>Standard ML-based security tools trigger binary anomaly flags without operational context. Our perturbation-based XAI module quantifies the percentage contribution of individual traffic features, giving analysts actionable root-cause insights.</a:t>
             </a:r>
           </a:p>
           <a:p>
             <a:pPr>
+              <a:spcBef>
+                <a:spcPts val="200"/>
+              </a:spcBef>
               <a:spcAft>
-                <a:spcPts val="600"/>
+                <a:spcPts val="800"/>
               </a:spcAft>
-              <a:defRPr b="1" sz="1200">
-                <a:solidFill>
-                  <a:srgbClr val="102C57"/>
-                </a:solidFill>
-              </a:defRPr>
             </a:pPr>
             <a:r>
-              <a:t>•  4. Destination-Only Flagging vs. True Source Attribution</a:t>
-            </a:r>
-            <a:br/>
-            <a:r>
-              <a:rPr b="0" sz="1100">
-                <a:solidFill>
-                  <a:srgbClr val="212529"/>
-                </a:solidFill>
+              <a:rPr sz="1550" b="1">
+                <a:solidFill>
+                  <a:srgbClr val="103460"/>
+                </a:solidFill>
+                <a:latin typeface="Calibri"/>
               </a:rPr>
-              <a:t>   Traditional network monitors flag the destination node receiving flood traffic, causing accidental denial of service through victim quarantine. Our framework traces IP/TCP flow headers back to the originating threat actor, preserving victim node operations.</a:t>
+              <a:t>•  4. Destination-Only Flagging vs. True Source Attribution: </a:t>
+            </a:r>
+            <a:r>
+              <a:rPr sz="1500" b="0">
+                <a:solidFill>
+                  <a:srgbClr val="1E1E1E"/>
+                </a:solidFill>
+                <a:latin typeface="Calibri"/>
+              </a:rPr>
+              <a:t>Traditional network monitors flag the destination node receiving flood traffic, causing accidental denial of service through victim quarantine. Our framework traces IP/TCP flow headers back to the originating threat actor, preserving victim node operations.</a:t>
             </a:r>
           </a:p>
           <a:p>
             <a:pPr>
+              <a:spcBef>
+                <a:spcPts val="200"/>
+              </a:spcBef>
               <a:spcAft>
-                <a:spcPts val="600"/>
+                <a:spcPts val="800"/>
               </a:spcAft>
-              <a:defRPr b="1" sz="1200">
-                <a:solidFill>
-                  <a:srgbClr val="102C57"/>
-                </a:solidFill>
-              </a:defRPr>
             </a:pPr>
             <a:r>
-              <a:t>•  5. Theoretical Simulations vs. Integrated Real-Time SOC Simulator</a:t>
-            </a:r>
-            <a:br/>
-            <a:r>
-              <a:rPr b="0" sz="1100">
-                <a:solidFill>
-                  <a:srgbClr val="212529"/>
-                </a:solidFill>
+              <a:rPr sz="1550" b="1">
+                <a:solidFill>
+                  <a:srgbClr val="103460"/>
+                </a:solidFill>
+                <a:latin typeface="Calibri"/>
               </a:rPr>
-              <a:t>   Most research relies on offline batch script simulations. We built an operational 3-tier SOC platform featuring live network topology, interactive attack injection, dynamic trust decay, and WebSocket streaming telemetry.</a:t>
+              <a:t>•  5. Theoretical Simulations vs. Integrated Real-Time SOC Simulator: </a:t>
+            </a:r>
+            <a:r>
+              <a:rPr sz="1500" b="0">
+                <a:solidFill>
+                  <a:srgbClr val="1E1E1E"/>
+                </a:solidFill>
+                <a:latin typeface="Calibri"/>
+              </a:rPr>
+              <a:t>Most research relies on offline batch script simulations. We built an operational 3-tier SOC platform featuring live network topology, interactive attack injection, dynamic trust decay, and WebSocket streaming telemetry.</a:t>
             </a:r>
           </a:p>
         </p:txBody>
@@ -9807,7 +10629,7 @@
         <p:spPr>
           <a:xfrm>
             <a:off x="731520" y="1234440"/>
-            <a:ext cx="10698480" cy="2651760"/>
+            <a:ext cx="10698480" cy="2926080"/>
           </a:xfrm>
         </p:spPr>
         <p:txBody>
@@ -9817,8 +10639,11 @@
           <a:lstStyle/>
           <a:p>
             <a:pPr>
+              <a:spcBef>
+                <a:spcPts val="100"/>
+              </a:spcBef>
               <a:spcAft>
-                <a:spcPts val="300"/>
+                <a:spcPts val="400"/>
               </a:spcAft>
               <a:defRPr b="1" sz="1150">
                 <a:solidFill>
@@ -9827,128 +10652,160 @@
               </a:defRPr>
             </a:pPr>
             <a:r>
+              <a:rPr sz="1450" b="1">
+                <a:solidFill>
+                  <a:srgbClr val="103460"/>
+                </a:solidFill>
+                <a:latin typeface="Calibri"/>
+              </a:rPr>
               <a:t>•  Privacy-Preserving Federated Architecture: </a:t>
             </a:r>
             <a:r>
-              <a:rPr b="0" sz="1100">
-                <a:solidFill>
-                  <a:srgbClr val="212529"/>
-                </a:solidFill>
+              <a:rPr sz="1400" b="0">
+                <a:solidFill>
+                  <a:srgbClr val="1E1E1E"/>
+                </a:solidFill>
+                <a:latin typeface="Calibri"/>
               </a:rPr>
               <a:t>Design and implement a decentralized FL framework for distributed network security without raw telemetry sharing.</a:t>
             </a:r>
           </a:p>
           <a:p>
             <a:pPr>
+              <a:spcBef>
+                <a:spcPts val="100"/>
+              </a:spcBef>
               <a:spcAft>
-                <a:spcPts val="300"/>
+                <a:spcPts val="400"/>
               </a:spcAft>
-              <a:defRPr b="1" sz="1150">
-                <a:solidFill>
-                  <a:srgbClr val="102C57"/>
-                </a:solidFill>
-              </a:defRPr>
             </a:pPr>
             <a:r>
+              <a:rPr sz="1450" b="1">
+                <a:solidFill>
+                  <a:srgbClr val="103460"/>
+                </a:solidFill>
+                <a:latin typeface="Calibri"/>
+              </a:rPr>
               <a:t>•  Unsupervised Isolation Forest Engine: </a:t>
             </a:r>
             <a:r>
-              <a:rPr b="0" sz="1100">
-                <a:solidFill>
-                  <a:srgbClr val="212529"/>
-                </a:solidFill>
+              <a:rPr sz="1400" b="0">
+                <a:solidFill>
+                  <a:srgbClr val="1E1E1E"/>
+                </a:solidFill>
+                <a:latin typeface="Calibri"/>
               </a:rPr>
               <a:t>Develop per-node anomaly detectors trained on 9 flow features to identify zero-day exploits without labeled datasets.</a:t>
             </a:r>
           </a:p>
           <a:p>
             <a:pPr>
+              <a:spcBef>
+                <a:spcPts val="100"/>
+              </a:spcBef>
               <a:spcAft>
-                <a:spcPts val="300"/>
+                <a:spcPts val="400"/>
               </a:spcAft>
-              <a:defRPr b="1" sz="1150">
-                <a:solidFill>
-                  <a:srgbClr val="102C57"/>
-                </a:solidFill>
-              </a:defRPr>
             </a:pPr>
             <a:r>
+              <a:rPr sz="1450" b="1">
+                <a:solidFill>
+                  <a:srgbClr val="103460"/>
+                </a:solidFill>
+                <a:latin typeface="Calibri"/>
+              </a:rPr>
               <a:t>•  Trust-Weighted FedAvg Aggregation: </a:t>
             </a:r>
             <a:r>
-              <a:rPr b="0" sz="1100">
-                <a:solidFill>
-                  <a:srgbClr val="212529"/>
-                </a:solidFill>
+              <a:rPr sz="1400" b="0">
+                <a:solidFill>
+                  <a:srgbClr val="1E1E1E"/>
+                </a:solidFill>
+                <a:latin typeface="Calibri"/>
               </a:rPr>
               <a:t>Formulate a poisoning-resilient aggregation mechanism that discounts or excludes compromised/quarantined nodes.</a:t>
             </a:r>
           </a:p>
           <a:p>
             <a:pPr>
+              <a:spcBef>
+                <a:spcPts val="100"/>
+              </a:spcBef>
               <a:spcAft>
-                <a:spcPts val="300"/>
+                <a:spcPts val="400"/>
               </a:spcAft>
-              <a:defRPr b="1" sz="1150">
-                <a:solidFill>
-                  <a:srgbClr val="102C57"/>
-                </a:solidFill>
-              </a:defRPr>
             </a:pPr>
             <a:r>
+              <a:rPr sz="1450" b="1">
+                <a:solidFill>
+                  <a:srgbClr val="103460"/>
+                </a:solidFill>
+                <a:latin typeface="Calibri"/>
+              </a:rPr>
               <a:t>•  Feature-Level Explainable AI (XAI): </a:t>
             </a:r>
             <a:r>
-              <a:rPr b="0" sz="1100">
-                <a:solidFill>
-                  <a:srgbClr val="212529"/>
-                </a:solidFill>
+              <a:rPr sz="1400" b="0">
+                <a:solidFill>
+                  <a:srgbClr val="1E1E1E"/>
+                </a:solidFill>
+                <a:latin typeface="Calibri"/>
               </a:rPr>
               <a:t>Build a perturbation analysis module attributing anomaly detections to specific traffic heuristic dimensions.</a:t>
             </a:r>
           </a:p>
           <a:p>
             <a:pPr>
+              <a:spcBef>
+                <a:spcPts val="100"/>
+              </a:spcBef>
               <a:spcAft>
-                <a:spcPts val="300"/>
+                <a:spcPts val="400"/>
               </a:spcAft>
-              <a:defRPr b="1" sz="1150">
-                <a:solidFill>
-                  <a:srgbClr val="102C57"/>
-                </a:solidFill>
-              </a:defRPr>
             </a:pPr>
             <a:r>
+              <a:rPr sz="1450" b="1">
+                <a:solidFill>
+                  <a:srgbClr val="103460"/>
+                </a:solidFill>
+                <a:latin typeface="Calibri"/>
+              </a:rPr>
               <a:t>•  Real-Time SOC Command Dashboard: </a:t>
             </a:r>
             <a:r>
-              <a:rPr b="0" sz="1100">
-                <a:solidFill>
-                  <a:srgbClr val="212529"/>
-                </a:solidFill>
+              <a:rPr sz="1400" b="0">
+                <a:solidFill>
+                  <a:srgbClr val="1E1E1E"/>
+                </a:solidFill>
+                <a:latin typeface="Calibri"/>
               </a:rPr>
               <a:t>Construct an interactive React/ReactFlow interface streaming live telemetry, topology graph, and DPI feeds via STOMP WebSockets.</a:t>
             </a:r>
           </a:p>
           <a:p>
             <a:pPr>
+              <a:spcBef>
+                <a:spcPts val="100"/>
+              </a:spcBef>
               <a:spcAft>
-                <a:spcPts val="300"/>
+                <a:spcPts val="400"/>
               </a:spcAft>
-              <a:defRPr b="1" sz="1150">
-                <a:solidFill>
-                  <a:srgbClr val="102C57"/>
-                </a:solidFill>
-              </a:defRPr>
             </a:pPr>
             <a:r>
+              <a:rPr sz="1450" b="1">
+                <a:solidFill>
+                  <a:srgbClr val="103460"/>
+                </a:solidFill>
+                <a:latin typeface="Calibri"/>
+              </a:rPr>
               <a:t>•  Source-Level Mitigation &amp; Auto-Quarantine: </a:t>
             </a:r>
             <a:r>
-              <a:rPr b="0" sz="1100">
-                <a:solidFill>
-                  <a:srgbClr val="212529"/>
-                </a:solidFill>
+              <a:rPr sz="1400" b="0">
+                <a:solidFill>
+                  <a:srgbClr val="1E1E1E"/>
+                </a:solidFill>
+                <a:latin typeface="Calibri"/>
               </a:rPr>
               <a:t>Demonstrate accurate TCP header attribution that dynamically penalizes trust and isolates the true attacker under sub-second latency.</a:t>
             </a:r>
@@ -10122,8 +10979,8 @@
         </p:nvSpPr>
         <p:spPr>
           <a:xfrm>
-            <a:off x="460248" y="3977639"/>
-            <a:ext cx="11523407" cy="640080"/>
+            <a:off x="731520" y="4297680"/>
+            <a:ext cx="10698480" cy="822960"/>
           </a:xfrm>
           <a:prstGeom prst="rect">
             <a:avLst/>
@@ -10137,6 +10994,9 @@
           <a:lstStyle/>
           <a:p>
             <a:pPr>
+              <a:spcAft>
+                <a:spcPts val="300"/>
+              </a:spcAft>
               <a:defRPr b="1" sz="1150">
                 <a:solidFill>
                   <a:srgbClr val="102C57"/>
@@ -10144,19 +11004,24 @@
               </a:defRPr>
             </a:pPr>
             <a:r>
+              <a:rPr sz="1400" b="1">
+                <a:solidFill>
+                  <a:srgbClr val="103460"/>
+                </a:solidFill>
+                <a:latin typeface="Calibri"/>
+              </a:rPr>
               <a:t>Identified Sustainable Development Goals: SDG 9 (Industry, Innovation &amp; Infrastructure) &amp; SDG 16 (Peace, Justice &amp; Strong Institutions)</a:t>
             </a:r>
           </a:p>
           <a:p>
-            <a:pPr>
-              <a:defRPr b="1" sz="1100">
-                <a:solidFill>
-                  <a:srgbClr val="1E50A0"/>
-                </a:solidFill>
-              </a:defRPr>
-            </a:pPr>
-            <a:r>
-              <a:t>Target Outcomes: Scopus-Indexed Conference Paper / Open-Source Product Demonstration</a:t>
+            <a:r>
+              <a:rPr sz="1400" b="1">
+                <a:solidFill>
+                  <a:srgbClr val="00783C"/>
+                </a:solidFill>
+                <a:latin typeface="Calibri"/>
+              </a:rPr>
+              <a:t>Target Outcomes: Conference Paper Submitted to NULLCON Goa 2027  |  Production-Ready SOC Software Prototype</a:t>
             </a:r>
           </a:p>
         </p:txBody>
@@ -10183,8 +11048,8 @@
         </p:blipFill>
         <p:spPr>
           <a:xfrm>
-            <a:off x="1990701" y="4778273"/>
-            <a:ext cx="1968651" cy="1578077"/>
+            <a:off x="3200400" y="5166360"/>
+            <a:ext cx="1371600" cy="1097280"/>
           </a:xfrm>
           <a:prstGeom prst="rect">
             <a:avLst/>
@@ -10213,8 +11078,8 @@
         </p:blipFill>
         <p:spPr>
           <a:xfrm>
-            <a:off x="5237545" y="4413148"/>
-            <a:ext cx="2447027" cy="2232651"/>
+            <a:off x="6858000" y="5166360"/>
+            <a:ext cx="1371600" cy="1097280"/>
           </a:xfrm>
           <a:prstGeom prst="rect">
             <a:avLst/>
@@ -10455,8 +11320,8 @@
         </p:blipFill>
         <p:spPr>
           <a:xfrm>
-            <a:off x="731520" y="1188720"/>
-            <a:ext cx="10698480" cy="4572000"/>
+            <a:off x="1097280" y="1280160"/>
+            <a:ext cx="9966960" cy="4754880"/>
           </a:xfrm>
           <a:prstGeom prst="rect">
             <a:avLst/>
@@ -10690,8 +11555,8 @@
           <p:nvPr/>
         </p:nvGraphicFramePr>
         <p:xfrm>
-          <a:off x="731520" y="1234440"/>
-          <a:ext cx="10698480" cy="4434840"/>
+          <a:off x="731520" y="1188720"/>
+          <a:ext cx="10698480" cy="4846320"/>
         </p:xfrm>
         <a:graphic>
           <a:graphicData uri="http://schemas.openxmlformats.org/drawingml/2006/table">
@@ -10720,6 +11585,12 @@
                         </a:defRPr>
                       </a:pPr>
                       <a:r>
+                        <a:rPr sz="1400" b="1">
+                          <a:solidFill>
+                            <a:srgbClr val="FFFFFF"/>
+                          </a:solidFill>
+                          <a:latin typeface="Calibri"/>
+                        </a:rPr>
                         <a:t>Req. ID</a:t>
                       </a:r>
                     </a:p>
@@ -10744,6 +11615,12 @@
                         </a:defRPr>
                       </a:pPr>
                       <a:r>
+                        <a:rPr sz="1400" b="1">
+                          <a:solidFill>
+                            <a:srgbClr val="FFFFFF"/>
+                          </a:solidFill>
+                          <a:latin typeface="Calibri"/>
+                        </a:rPr>
                         <a:t>Functional Requirement Description</a:t>
                       </a:r>
                     </a:p>
@@ -10768,6 +11645,12 @@
                         </a:defRPr>
                       </a:pPr>
                       <a:r>
+                        <a:rPr sz="1400" b="1">
+                          <a:solidFill>
+                            <a:srgbClr val="FFFFFF"/>
+                          </a:solidFill>
+                          <a:latin typeface="Calibri"/>
+                        </a:rPr>
                         <a:t>Priority</a:t>
                       </a:r>
                     </a:p>
@@ -10792,6 +11675,12 @@
                         </a:defRPr>
                       </a:pPr>
                       <a:r>
+                        <a:rPr sz="1400" b="1">
+                          <a:solidFill>
+                            <a:srgbClr val="FFFFFF"/>
+                          </a:solidFill>
+                          <a:latin typeface="Calibri"/>
+                        </a:rPr>
                         <a:t>Review 3 Status</a:t>
                       </a:r>
                     </a:p>
@@ -10818,6 +11707,12 @@
                         </a:defRPr>
                       </a:pPr>
                       <a:r>
+                        <a:rPr sz="1250" b="1">
+                          <a:solidFill>
+                            <a:srgbClr val="1E1E1E"/>
+                          </a:solidFill>
+                          <a:latin typeface="Calibri"/>
+                        </a:rPr>
                         <a:t>FR-01</a:t>
                       </a:r>
                     </a:p>
@@ -10842,6 +11737,12 @@
                         </a:defRPr>
                       </a:pPr>
                       <a:r>
+                        <a:rPr sz="1250">
+                          <a:solidFill>
+                            <a:srgbClr val="1E1E1E"/>
+                          </a:solidFill>
+                          <a:latin typeface="Calibri"/>
+                        </a:rPr>
                         <a:t>Simulate an enterprise network topology with 16 nodes across 4 architectural tiers</a:t>
                       </a:r>
                     </a:p>
@@ -10866,6 +11767,12 @@
                         </a:defRPr>
                       </a:pPr>
                       <a:r>
+                        <a:rPr sz="1250" b="1">
+                          <a:solidFill>
+                            <a:srgbClr val="1E1E1E"/>
+                          </a:solidFill>
+                          <a:latin typeface="Calibri"/>
+                        </a:rPr>
                         <a:t>High</a:t>
                       </a:r>
                     </a:p>
@@ -10890,6 +11797,12 @@
                         </a:defRPr>
                       </a:pPr>
                       <a:r>
+                        <a:rPr sz="1250" b="1">
+                          <a:solidFill>
+                            <a:srgbClr val="1E1E1E"/>
+                          </a:solidFill>
+                          <a:latin typeface="Calibri"/>
+                        </a:rPr>
                         <a:t>Completed</a:t>
                       </a:r>
                     </a:p>
@@ -10916,6 +11829,12 @@
                         </a:defRPr>
                       </a:pPr>
                       <a:r>
+                        <a:rPr sz="1250" b="1">
+                          <a:solidFill>
+                            <a:srgbClr val="1E1E1E"/>
+                          </a:solidFill>
+                          <a:latin typeface="Calibri"/>
+                        </a:rPr>
                         <a:t>FR-02</a:t>
                       </a:r>
                     </a:p>
@@ -10940,6 +11859,12 @@
                         </a:defRPr>
                       </a:pPr>
                       <a:r>
+                        <a:rPr sz="1250">
+                          <a:solidFill>
+                            <a:srgbClr val="1E1E1E"/>
+                          </a:solidFill>
+                          <a:latin typeface="Calibri"/>
+                        </a:rPr>
                         <a:t>Generate realistic node-profile-specific normal traffic (HTTP, SSH, DB, IoT protocols)</a:t>
                       </a:r>
                     </a:p>
@@ -10964,6 +11889,12 @@
                         </a:defRPr>
                       </a:pPr>
                       <a:r>
+                        <a:rPr sz="1250" b="1">
+                          <a:solidFill>
+                            <a:srgbClr val="1E1E1E"/>
+                          </a:solidFill>
+                          <a:latin typeface="Calibri"/>
+                        </a:rPr>
                         <a:t>High</a:t>
                       </a:r>
                     </a:p>
@@ -10988,6 +11919,12 @@
                         </a:defRPr>
                       </a:pPr>
                       <a:r>
+                        <a:rPr sz="1250" b="1">
+                          <a:solidFill>
+                            <a:srgbClr val="1E1E1E"/>
+                          </a:solidFill>
+                          <a:latin typeface="Calibri"/>
+                        </a:rPr>
                         <a:t>Completed</a:t>
                       </a:r>
                     </a:p>
@@ -11014,6 +11951,12 @@
                         </a:defRPr>
                       </a:pPr>
                       <a:r>
+                        <a:rPr sz="1250" b="1">
+                          <a:solidFill>
+                            <a:srgbClr val="1E1E1E"/>
+                          </a:solidFill>
+                          <a:latin typeface="Calibri"/>
+                        </a:rPr>
                         <a:t>FR-03</a:t>
                       </a:r>
                     </a:p>
@@ -11038,6 +11981,12 @@
                         </a:defRPr>
                       </a:pPr>
                       <a:r>
+                        <a:rPr sz="1250">
+                          <a:solidFill>
+                            <a:srgbClr val="1E1E1E"/>
+                          </a:solidFill>
+                          <a:latin typeface="Calibri"/>
+                        </a:rPr>
                         <a:t>Support live injection of 6 attack types (DDoS, Port Scan, Brute Force, Malware, Exfiltration, Recon)</a:t>
                       </a:r>
                     </a:p>
@@ -11062,6 +12011,12 @@
                         </a:defRPr>
                       </a:pPr>
                       <a:r>
+                        <a:rPr sz="1250" b="1">
+                          <a:solidFill>
+                            <a:srgbClr val="1E1E1E"/>
+                          </a:solidFill>
+                          <a:latin typeface="Calibri"/>
+                        </a:rPr>
                         <a:t>High</a:t>
                       </a:r>
                     </a:p>
@@ -11086,6 +12041,12 @@
                         </a:defRPr>
                       </a:pPr>
                       <a:r>
+                        <a:rPr sz="1250" b="1">
+                          <a:solidFill>
+                            <a:srgbClr val="1E1E1E"/>
+                          </a:solidFill>
+                          <a:latin typeface="Calibri"/>
+                        </a:rPr>
                         <a:t>Completed</a:t>
                       </a:r>
                     </a:p>
@@ -11112,6 +12073,12 @@
                         </a:defRPr>
                       </a:pPr>
                       <a:r>
+                        <a:rPr sz="1250" b="1">
+                          <a:solidFill>
+                            <a:srgbClr val="1E1E1E"/>
+                          </a:solidFill>
+                          <a:latin typeface="Calibri"/>
+                        </a:rPr>
                         <a:t>FR-04</a:t>
                       </a:r>
                     </a:p>
@@ -11136,6 +12103,12 @@
                         </a:defRPr>
                       </a:pPr>
                       <a:r>
+                        <a:rPr sz="1250">
+                          <a:solidFill>
+                            <a:srgbClr val="1E1E1E"/>
+                          </a:solidFill>
+                          <a:latin typeface="Calibri"/>
+                        </a:rPr>
                         <a:t>Train per-node unsupervised Isolation Forest models on 9 engineered statistical flow dimensions</a:t>
                       </a:r>
                     </a:p>
@@ -11160,6 +12133,12 @@
                         </a:defRPr>
                       </a:pPr>
                       <a:r>
+                        <a:rPr sz="1250" b="1">
+                          <a:solidFill>
+                            <a:srgbClr val="1E1E1E"/>
+                          </a:solidFill>
+                          <a:latin typeface="Calibri"/>
+                        </a:rPr>
                         <a:t>High</a:t>
                       </a:r>
                     </a:p>
@@ -11184,6 +12163,12 @@
                         </a:defRPr>
                       </a:pPr>
                       <a:r>
+                        <a:rPr sz="1250" b="1">
+                          <a:solidFill>
+                            <a:srgbClr val="1E1E1E"/>
+                          </a:solidFill>
+                          <a:latin typeface="Calibri"/>
+                        </a:rPr>
                         <a:t>Completed</a:t>
                       </a:r>
                     </a:p>
@@ -11210,6 +12195,12 @@
                         </a:defRPr>
                       </a:pPr>
                       <a:r>
+                        <a:rPr sz="1250" b="1">
+                          <a:solidFill>
+                            <a:srgbClr val="1E1E1E"/>
+                          </a:solidFill>
+                          <a:latin typeface="Calibri"/>
+                        </a:rPr>
                         <a:t>FR-05</a:t>
                       </a:r>
                     </a:p>
@@ -11234,6 +12225,12 @@
                         </a:defRPr>
                       </a:pPr>
                       <a:r>
+                        <a:rPr sz="1250">
+                          <a:solidFill>
+                            <a:srgbClr val="1E1E1E"/>
+                          </a:solidFill>
+                          <a:latin typeface="Calibri"/>
+                        </a:rPr>
                         <a:t>Perform trust-weighted Federated Averaging (FedAvg) of model parameters every 20 simulation ticks</a:t>
                       </a:r>
                     </a:p>
@@ -11258,6 +12255,12 @@
                         </a:defRPr>
                       </a:pPr>
                       <a:r>
+                        <a:rPr sz="1250" b="1">
+                          <a:solidFill>
+                            <a:srgbClr val="1E1E1E"/>
+                          </a:solidFill>
+                          <a:latin typeface="Calibri"/>
+                        </a:rPr>
                         <a:t>High</a:t>
                       </a:r>
                     </a:p>
@@ -11282,6 +12285,12 @@
                         </a:defRPr>
                       </a:pPr>
                       <a:r>
+                        <a:rPr sz="1250" b="1">
+                          <a:solidFill>
+                            <a:srgbClr val="1E1E1E"/>
+                          </a:solidFill>
+                          <a:latin typeface="Calibri"/>
+                        </a:rPr>
                         <a:t>Completed</a:t>
                       </a:r>
                     </a:p>
@@ -11308,6 +12317,12 @@
                         </a:defRPr>
                       </a:pPr>
                       <a:r>
+                        <a:rPr sz="1250" b="1">
+                          <a:solidFill>
+                            <a:srgbClr val="1E1E1E"/>
+                          </a:solidFill>
+                          <a:latin typeface="Calibri"/>
+                        </a:rPr>
                         <a:t>FR-06</a:t>
                       </a:r>
                     </a:p>
@@ -11332,6 +12347,12 @@
                         </a:defRPr>
                       </a:pPr>
                       <a:r>
+                        <a:rPr sz="1250">
+                          <a:solidFill>
+                            <a:srgbClr val="1E1E1E"/>
+                          </a:solidFill>
+                          <a:latin typeface="Calibri"/>
+                        </a:rPr>
                         <a:t>Automatically exclude quarantined or compromised nodes from participating in federated rounds</a:t>
                       </a:r>
                     </a:p>
@@ -11356,6 +12377,12 @@
                         </a:defRPr>
                       </a:pPr>
                       <a:r>
+                        <a:rPr sz="1250" b="1">
+                          <a:solidFill>
+                            <a:srgbClr val="1E1E1E"/>
+                          </a:solidFill>
+                          <a:latin typeface="Calibri"/>
+                        </a:rPr>
                         <a:t>Medium</a:t>
                       </a:r>
                     </a:p>
@@ -11380,6 +12407,12 @@
                         </a:defRPr>
                       </a:pPr>
                       <a:r>
+                        <a:rPr sz="1250" b="1">
+                          <a:solidFill>
+                            <a:srgbClr val="1E1E1E"/>
+                          </a:solidFill>
+                          <a:latin typeface="Calibri"/>
+                        </a:rPr>
                         <a:t>Completed</a:t>
                       </a:r>
                     </a:p>
@@ -11406,6 +12439,12 @@
                         </a:defRPr>
                       </a:pPr>
                       <a:r>
+                        <a:rPr sz="1250" b="1">
+                          <a:solidFill>
+                            <a:srgbClr val="1E1E1E"/>
+                          </a:solidFill>
+                          <a:latin typeface="Calibri"/>
+                        </a:rPr>
                         <a:t>FR-07</a:t>
                       </a:r>
                     </a:p>
@@ -11430,6 +12469,12 @@
                         </a:defRPr>
                       </a:pPr>
                       <a:r>
+                        <a:rPr sz="1250">
+                          <a:solidFill>
+                            <a:srgbClr val="1E1E1E"/>
+                          </a:solidFill>
+                          <a:latin typeface="Calibri"/>
+                        </a:rPr>
                         <a:t>Provide sub-second anomaly detection with TCP header-based source-level attribution</a:t>
                       </a:r>
                     </a:p>
@@ -11454,6 +12499,12 @@
                         </a:defRPr>
                       </a:pPr>
                       <a:r>
+                        <a:rPr sz="1250" b="1">
+                          <a:solidFill>
+                            <a:srgbClr val="1E1E1E"/>
+                          </a:solidFill>
+                          <a:latin typeface="Calibri"/>
+                        </a:rPr>
                         <a:t>High</a:t>
                       </a:r>
                     </a:p>
@@ -11478,6 +12529,12 @@
                         </a:defRPr>
                       </a:pPr>
                       <a:r>
+                        <a:rPr sz="1250" b="1">
+                          <a:solidFill>
+                            <a:srgbClr val="1E1E1E"/>
+                          </a:solidFill>
+                          <a:latin typeface="Calibri"/>
+                        </a:rPr>
                         <a:t>Completed</a:t>
                       </a:r>
                     </a:p>
@@ -11504,6 +12561,12 @@
                         </a:defRPr>
                       </a:pPr>
                       <a:r>
+                        <a:rPr sz="1250" b="1">
+                          <a:solidFill>
+                            <a:srgbClr val="1E1E1E"/>
+                          </a:solidFill>
+                          <a:latin typeface="Calibri"/>
+                        </a:rPr>
                         <a:t>FR-08</a:t>
                       </a:r>
                     </a:p>
@@ -11528,6 +12591,12 @@
                         </a:defRPr>
                       </a:pPr>
                       <a:r>
+                        <a:rPr sz="1250">
+                          <a:solidFill>
+                            <a:srgbClr val="1E1E1E"/>
+                          </a:solidFill>
+                          <a:latin typeface="Calibri"/>
+                        </a:rPr>
                         <a:t>Implement dynamic trust scoring with decay (2.5/tick for suspicious nodes) and recovery (1.0/tick)</a:t>
                       </a:r>
                     </a:p>
@@ -11552,6 +12621,12 @@
                         </a:defRPr>
                       </a:pPr>
                       <a:r>
+                        <a:rPr sz="1250" b="1">
+                          <a:solidFill>
+                            <a:srgbClr val="1E1E1E"/>
+                          </a:solidFill>
+                          <a:latin typeface="Calibri"/>
+                        </a:rPr>
                         <a:t>High</a:t>
                       </a:r>
                     </a:p>
@@ -11576,6 +12651,12 @@
                         </a:defRPr>
                       </a:pPr>
                       <a:r>
+                        <a:rPr sz="1250" b="1">
+                          <a:solidFill>
+                            <a:srgbClr val="1E1E1E"/>
+                          </a:solidFill>
+                          <a:latin typeface="Calibri"/>
+                        </a:rPr>
                         <a:t>Completed</a:t>
                       </a:r>
                     </a:p>
@@ -11602,6 +12683,12 @@
                         </a:defRPr>
                       </a:pPr>
                       <a:r>
+                        <a:rPr sz="1250" b="1">
+                          <a:solidFill>
+                            <a:srgbClr val="1E1E1E"/>
+                          </a:solidFill>
+                          <a:latin typeface="Calibri"/>
+                        </a:rPr>
                         <a:t>FR-09</a:t>
                       </a:r>
                     </a:p>
@@ -11626,6 +12713,12 @@
                         </a:defRPr>
                       </a:pPr>
                       <a:r>
+                        <a:rPr sz="1250">
+                          <a:solidFill>
+                            <a:srgbClr val="1E1E1E"/>
+                          </a:solidFill>
+                          <a:latin typeface="Calibri"/>
+                        </a:rPr>
                         <a:t>Automate node isolation and quarantine when trust score falls below threshold of 30</a:t>
                       </a:r>
                     </a:p>
@@ -11650,6 +12743,12 @@
                         </a:defRPr>
                       </a:pPr>
                       <a:r>
+                        <a:rPr sz="1250" b="1">
+                          <a:solidFill>
+                            <a:srgbClr val="1E1E1E"/>
+                          </a:solidFill>
+                          <a:latin typeface="Calibri"/>
+                        </a:rPr>
                         <a:t>Medium</a:t>
                       </a:r>
                     </a:p>
@@ -11674,6 +12773,12 @@
                         </a:defRPr>
                       </a:pPr>
                       <a:r>
+                        <a:rPr sz="1250" b="1">
+                          <a:solidFill>
+                            <a:srgbClr val="1E1E1E"/>
+                          </a:solidFill>
+                          <a:latin typeface="Calibri"/>
+                        </a:rPr>
                         <a:t>Completed</a:t>
                       </a:r>
                     </a:p>
@@ -11700,6 +12805,12 @@
                         </a:defRPr>
                       </a:pPr>
                       <a:r>
+                        <a:rPr sz="1250" b="1">
+                          <a:solidFill>
+                            <a:srgbClr val="1E1E1E"/>
+                          </a:solidFill>
+                          <a:latin typeface="Calibri"/>
+                        </a:rPr>
                         <a:t>FR-10</a:t>
                       </a:r>
                     </a:p>
@@ -11724,6 +12835,12 @@
                         </a:defRPr>
                       </a:pPr>
                       <a:r>
+                        <a:rPr sz="1250">
+                          <a:solidFill>
+                            <a:srgbClr val="1E1E1E"/>
+                          </a:solidFill>
+                          <a:latin typeface="Calibri"/>
+                        </a:rPr>
                         <a:t>Generate feature-level Explainable AI (XAI) perturbation explanations and stream via WebSocket</a:t>
                       </a:r>
                     </a:p>
@@ -11748,6 +12865,12 @@
                         </a:defRPr>
                       </a:pPr>
                       <a:r>
+                        <a:rPr sz="1250" b="1">
+                          <a:solidFill>
+                            <a:srgbClr val="1E1E1E"/>
+                          </a:solidFill>
+                          <a:latin typeface="Calibri"/>
+                        </a:rPr>
                         <a:t>High</a:t>
                       </a:r>
                     </a:p>
@@ -11772,6 +12895,12 @@
                         </a:defRPr>
                       </a:pPr>
                       <a:r>
+                        <a:rPr sz="1250" b="1">
+                          <a:solidFill>
+                            <a:srgbClr val="1E1E1E"/>
+                          </a:solidFill>
+                          <a:latin typeface="Calibri"/>
+                        </a:rPr>
                         <a:t>Completed</a:t>
                       </a:r>
                     </a:p>

</xml_diff>